<commit_message>
Reframe deck with problem-led hook and action plan
Co-authored-by: aviyashaya-tech <aviyashaya-tech@users.noreply.github.com>
</commit_message>
<xml_diff>
--- a/decks/avi-yashaya-consulting-deck.pptx
+++ b/decks/avi-yashaya-consulting-deck.pptx
@@ -3248,7 +3248,8 @@
                 <a:latin typeface="Calibri"/>
               </a:rPr>
               <a:t>Partner &amp; CEO, Mahanakhon Beverages Co., Ltd
-NPD Consultant for Beverage Growth Across Southeast Asia</a:t>
+NPD Consultant for Beverage Growth Across Southeast Asia
+Built an operating platform behind products delivering $2M+ annual sell-through</a:t>
             </a:r>
           </a:p>
         </p:txBody>
@@ -3827,7 +3828,7 @@
                 </a:solidFill>
                 <a:latin typeface="Calibri"/>
               </a:rPr>
-              <a:t>Available for consulting mandates with larger beverage companies and growth-focused regional operators.</a:t>
+              <a:t>Let's leverage the region's best strategic partners for R&amp;D, production, and route to market to bring Asia's next big beverage to life.</a:t>
             </a:r>
           </a:p>
         </p:txBody>
@@ -3940,7 +3941,7 @@
                 </a:solidFill>
                 <a:latin typeface="Calibri"/>
               </a:rPr>
-              <a:t>Profile</a:t>
+              <a:t>Market Reality</a:t>
             </a:r>
           </a:p>
         </p:txBody>
@@ -3974,7 +3975,7 @@
                 </a:solidFill>
                 <a:latin typeface="Calibri"/>
               </a:rPr>
-              <a:t>Built for Execution, Not Theory</a:t>
+              <a:t>The Double-Edged Dilemma for Beverage Producers in Southeast Asia</a:t>
             </a:r>
           </a:p>
         </p:txBody>
@@ -4013,7 +4014,7 @@
               </a:defRPr>
             </a:pPr>
             <a:r>
-              <a:t>10+ years building beverage brands, operations, and route-to-market systems across Thailand, Laos, and Vietnam.</a:t>
+              <a:t>SMEs with ambitions of building Southeast Asia's next big beverage brand collide with industrial MOQs and harsh logistical, supply chain, and cash flow crises.</a:t>
             </a:r>
           </a:p>
           <a:p>
@@ -4029,7 +4030,7 @@
               </a:defRPr>
             </a:pPr>
             <a:r>
-              <a:t>Led launches that now generate over $2M annual sell-through in retail and on-trade channels.</a:t>
+              <a:t>Institutional players struggle to keep up with fast consumer shifts because their data is often past its best-before date by the end of a slow development timeline.</a:t>
             </a:r>
           </a:p>
           <a:p>
@@ -4045,7 +4046,7 @@
               </a:defRPr>
             </a:pPr>
             <a:r>
-              <a:t>Hands-on leadership across sourcing, production, packaging, pricing, and distribution—not AI concept work.</a:t>
+              <a:t>Result: one side cannot scale efficiently, the other cannot adapt fast enough, and both lose speed, margin, and market relevance.</a:t>
             </a:r>
           </a:p>
           <a:p>
@@ -4061,7 +4062,7 @@
               </a:defRPr>
             </a:pPr>
             <a:r>
-              <a:t>Trusted operator for companies that need profitable market entry and scale in Southeast Asia.</a:t>
+              <a:t>This is the exact operating gap I help clients close.</a:t>
             </a:r>
           </a:p>
         </p:txBody>
@@ -4174,7 +4175,7 @@
                 </a:solidFill>
                 <a:latin typeface="Calibri"/>
               </a:rPr>
-              <a:t>Value Proposition</a:t>
+              <a:t>Action Plan</a:t>
             </a:r>
           </a:p>
         </p:txBody>
@@ -4208,7 +4209,7 @@
                 </a:solidFill>
                 <a:latin typeface="Calibri"/>
               </a:rPr>
-              <a:t>What Enterprise Beverage Teams Bring Me In To Solve</a:t>
+              <a:t>Actionable System I Implement (Built from 10+ Years in Market)</a:t>
             </a:r>
           </a:p>
         </p:txBody>
@@ -4247,7 +4248,7 @@
               </a:defRPr>
             </a:pPr>
             <a:r>
-              <a:t>Build a resilient, multi-country beverage supply chain from raw materials to retail shelf.</a:t>
+              <a:t>Step 1 - Partner stack: leverage the region's strongest strategic partners for R&amp;D, production, packaging, and route to market.</a:t>
             </a:r>
           </a:p>
           <a:p>
@@ -4263,7 +4264,7 @@
               </a:defRPr>
             </a:pPr>
             <a:r>
-              <a:t>Design and validate product-market fit for Beer, Spirits, and RTD portfolios in Southeast Asia.</a:t>
+              <a:t>Step 2 - MOQ-aware build plan: sequence pilot-to-scale production in Thailand and Vietnam across Brewery, Distillery, and RTD to avoid cash burn.</a:t>
             </a:r>
           </a:p>
           <a:p>
@@ -4279,7 +4280,7 @@
               </a:defRPr>
             </a:pPr>
             <a:r>
-              <a:t>Convert distributor conversations into measurable listings, volume, and margin expansion.</a:t>
+              <a:t>Step 3 - Supply continuity by design: lock critical raw material flow, including hops from USA and New Zealand, with quality/spec alignment and dual-lane planning.</a:t>
             </a:r>
           </a:p>
           <a:p>
@@ -4295,7 +4296,100 @@
               </a:defRPr>
             </a:pPr>
             <a:r>
-              <a:t>De-risk new market entries with local manufacturing, regulatory, and channel execution plans.</a:t>
+              <a:t>Step 4 - Commercial math: build channel-specific price architecture and margin logic before launch, not after discounting pressure starts.</a:t>
+            </a:r>
+          </a:p>
+          <a:p>
+            <a:pPr>
+              <a:spcAft>
+                <a:spcPts val="1400"/>
+              </a:spcAft>
+              <a:defRPr sz="2000">
+                <a:solidFill>
+                  <a:srgbClr val="364559"/>
+                </a:solidFill>
+                <a:latin typeface="Calibri"/>
+              </a:defRPr>
+            </a:pPr>
+            <a:r>
+              <a:t>Step 5 - Execution cadence: run launch governance that shortens development-to-shelf cycles and keeps decisions tied to live market signals.</a:t>
+            </a:r>
+          </a:p>
+        </p:txBody>
+      </p:sp>
+      <p:sp>
+        <p:nvSpPr>
+          <p:cNvPr id="6" name="Rectangle 5"/>
+          <p:cNvSpPr/>
+          <p:nvPr/>
+        </p:nvSpPr>
+        <p:spPr>
+          <a:xfrm>
+            <a:off x="868680" y="6035040"/>
+            <a:ext cx="10789920" cy="27432"/>
+          </a:xfrm>
+          <a:prstGeom prst="rect">
+            <a:avLst/>
+          </a:prstGeom>
+          <a:solidFill>
+            <a:srgbClr val="C79948"/>
+          </a:solidFill>
+          <a:ln>
+            <a:noFill/>
+          </a:ln>
+        </p:spPr>
+        <p:style>
+          <a:lnRef idx="1">
+            <a:schemeClr val="accent1"/>
+          </a:lnRef>
+          <a:fillRef idx="3">
+            <a:schemeClr val="accent1"/>
+          </a:fillRef>
+          <a:effectRef idx="2">
+            <a:schemeClr val="accent1"/>
+          </a:effectRef>
+          <a:fontRef idx="minor">
+            <a:schemeClr val="lt1"/>
+          </a:fontRef>
+        </p:style>
+        <p:txBody>
+          <a:bodyPr rtlCol="0" anchor="ctr"/>
+          <a:lstStyle/>
+          <a:p>
+            <a:pPr algn="ctr"/>
+          </a:p>
+        </p:txBody>
+      </p:sp>
+      <p:sp>
+        <p:nvSpPr>
+          <p:cNvPr id="7" name="TextBox 6"/>
+          <p:cNvSpPr txBox="1"/>
+          <p:nvPr/>
+        </p:nvSpPr>
+        <p:spPr>
+          <a:xfrm>
+            <a:off x="868680" y="6144768"/>
+            <a:ext cx="10789920" cy="548640"/>
+          </a:xfrm>
+          <a:prstGeom prst="rect">
+            <a:avLst/>
+          </a:prstGeom>
+          <a:noFill/>
+        </p:spPr>
+        <p:txBody>
+          <a:bodyPr wrap="none">
+            <a:spAutoFit/>
+          </a:bodyPr>
+          <a:lstStyle/>
+          <a:p>
+            <a:r>
+              <a:rPr sz="1400">
+                <a:solidFill>
+                  <a:srgbClr val="364559"/>
+                </a:solidFill>
+                <a:latin typeface="Calibri"/>
+              </a:rPr>
+              <a:t>Let's leverage the region's best strategic partners and build systems that bring Asia's next big beverage to life.</a:t>
             </a:r>
           </a:p>
         </p:txBody>

</xml_diff>

<commit_message>
Integrate Mahanakhon logo and concept gallery slide
Co-authored-by: aviyashaya-tech <aviyashaya-tech@users.noreply.github.com>
</commit_message>
<xml_diff>
--- a/decks/avi-yashaya-consulting-deck.pptx
+++ b/decks/avi-yashaya-consulting-deck.pptx
@@ -16,6 +16,7 @@
     <p:sldId id="264" r:id="rId15"/>
     <p:sldId id="265" r:id="rId16"/>
     <p:sldId id="266" r:id="rId17"/>
+    <p:sldId id="267" r:id="rId18"/>
   </p:sldIdLst>
   <p:sldSz cx="12188952" cy="6858000" type="screen4x3"/>
   <p:notesSz cx="6858000" cy="9144000"/>
@@ -3288,6 +3289,75 @@
           </a:p>
         </p:txBody>
       </p:sp>
+      <p:sp>
+        <p:nvSpPr>
+          <p:cNvPr id="7" name="Rectangle 6"/>
+          <p:cNvSpPr/>
+          <p:nvPr/>
+        </p:nvSpPr>
+        <p:spPr>
+          <a:xfrm>
+            <a:off x="9464040" y="658368"/>
+            <a:ext cx="2057400" cy="1078992"/>
+          </a:xfrm>
+          <a:prstGeom prst="rect">
+            <a:avLst/>
+          </a:prstGeom>
+          <a:solidFill>
+            <a:srgbClr val="FFFFFF"/>
+          </a:solidFill>
+          <a:ln>
+            <a:solidFill>
+              <a:srgbClr val="D8DFE8"/>
+            </a:solidFill>
+          </a:ln>
+        </p:spPr>
+        <p:style>
+          <a:lnRef idx="1">
+            <a:schemeClr val="accent1"/>
+          </a:lnRef>
+          <a:fillRef idx="3">
+            <a:schemeClr val="accent1"/>
+          </a:fillRef>
+          <a:effectRef idx="2">
+            <a:schemeClr val="accent1"/>
+          </a:effectRef>
+          <a:fontRef idx="minor">
+            <a:schemeClr val="lt1"/>
+          </a:fontRef>
+        </p:style>
+        <p:txBody>
+          <a:bodyPr rtlCol="0" anchor="ctr"/>
+          <a:lstStyle/>
+          <a:p>
+            <a:pPr algn="ctr"/>
+          </a:p>
+        </p:txBody>
+      </p:sp>
+      <p:pic>
+        <p:nvPicPr>
+          <p:cNvPr id="8" name="Picture 7" descr="mahanakhon-brewery-logo-hd.jpeg"/>
+          <p:cNvPicPr>
+            <a:picLocks noChangeAspect="1"/>
+          </p:cNvPicPr>
+          <p:nvPr/>
+        </p:nvPicPr>
+        <p:blipFill>
+          <a:blip r:embed="rId2"/>
+          <a:stretch>
+            <a:fillRect/>
+          </a:stretch>
+        </p:blipFill>
+        <p:spPr>
+          <a:xfrm>
+            <a:off x="9573768" y="722376"/>
+            <a:ext cx="1828800" cy="786384"/>
+          </a:xfrm>
+          <a:prstGeom prst="rect">
+            <a:avLst/>
+          </a:prstGeom>
+        </p:spPr>
+      </p:pic>
     </p:spTree>
   </p:cSld>
   <p:clrMapOvr>
@@ -3396,7 +3466,7 @@
                 </a:solidFill>
                 <a:latin typeface="Calibri"/>
               </a:rPr>
-              <a:t>Ideal Clients</a:t>
+              <a:t>Engagement Model</a:t>
             </a:r>
           </a:p>
         </p:txBody>
@@ -3424,27 +3494,151 @@
           <a:lstStyle/>
           <a:p>
             <a:r>
-              <a:rPr sz="3400" b="1">
+              <a:rPr sz="3000" b="1">
                 <a:solidFill>
                   <a:srgbClr val="12233F"/>
                 </a:solidFill>
                 <a:latin typeface="Calibri"/>
               </a:rPr>
-              <a:t>Best Fit Engagements</a:t>
-            </a:r>
-          </a:p>
-        </p:txBody>
-      </p:sp>
-      <p:sp>
-        <p:nvSpPr>
-          <p:cNvPr id="5" name="TextBox 4"/>
+              <a:t>How I Work With Beverage Companies</a:t>
+            </a:r>
+          </a:p>
+        </p:txBody>
+      </p:sp>
+      <p:sp>
+        <p:nvSpPr>
+          <p:cNvPr id="5" name="Rectangle 4"/>
+          <p:cNvSpPr/>
+          <p:nvPr/>
+        </p:nvSpPr>
+        <p:spPr>
+          <a:xfrm>
+            <a:off x="640080" y="1737360"/>
+            <a:ext cx="5440680" cy="4754880"/>
+          </a:xfrm>
+          <a:prstGeom prst="rect">
+            <a:avLst/>
+          </a:prstGeom>
+          <a:solidFill>
+            <a:srgbClr val="FFFFFF"/>
+          </a:solidFill>
+          <a:ln>
+            <a:solidFill>
+              <a:srgbClr val="D8DFE8"/>
+            </a:solidFill>
+          </a:ln>
+        </p:spPr>
+        <p:style>
+          <a:lnRef idx="1">
+            <a:schemeClr val="accent1"/>
+          </a:lnRef>
+          <a:fillRef idx="3">
+            <a:schemeClr val="accent1"/>
+          </a:fillRef>
+          <a:effectRef idx="2">
+            <a:schemeClr val="accent1"/>
+          </a:effectRef>
+          <a:fontRef idx="minor">
+            <a:schemeClr val="lt1"/>
+          </a:fontRef>
+        </p:style>
+        <p:txBody>
+          <a:bodyPr rtlCol="0" anchor="ctr"/>
+          <a:lstStyle/>
+          <a:p>
+            <a:pPr algn="ctr"/>
+          </a:p>
+        </p:txBody>
+      </p:sp>
+      <p:sp>
+        <p:nvSpPr>
+          <p:cNvPr id="6" name="Rectangle 5"/>
+          <p:cNvSpPr/>
+          <p:nvPr/>
+        </p:nvSpPr>
+        <p:spPr>
+          <a:xfrm>
+            <a:off x="6126480" y="1737360"/>
+            <a:ext cx="5440680" cy="4754880"/>
+          </a:xfrm>
+          <a:prstGeom prst="rect">
+            <a:avLst/>
+          </a:prstGeom>
+          <a:solidFill>
+            <a:srgbClr val="FFFFFF"/>
+          </a:solidFill>
+          <a:ln>
+            <a:solidFill>
+              <a:srgbClr val="D8DFE8"/>
+            </a:solidFill>
+          </a:ln>
+        </p:spPr>
+        <p:style>
+          <a:lnRef idx="1">
+            <a:schemeClr val="accent1"/>
+          </a:lnRef>
+          <a:fillRef idx="3">
+            <a:schemeClr val="accent1"/>
+          </a:fillRef>
+          <a:effectRef idx="2">
+            <a:schemeClr val="accent1"/>
+          </a:effectRef>
+          <a:fontRef idx="minor">
+            <a:schemeClr val="lt1"/>
+          </a:fontRef>
+        </p:style>
+        <p:txBody>
+          <a:bodyPr rtlCol="0" anchor="ctr"/>
+          <a:lstStyle/>
+          <a:p>
+            <a:pPr algn="ctr"/>
+          </a:p>
+        </p:txBody>
+      </p:sp>
+      <p:sp>
+        <p:nvSpPr>
+          <p:cNvPr id="7" name="TextBox 6"/>
           <p:cNvSpPr txBox="1"/>
           <p:nvPr/>
         </p:nvSpPr>
         <p:spPr>
           <a:xfrm>
-            <a:off x="868680" y="1645920"/>
-            <a:ext cx="10789920" cy="4480560"/>
+            <a:off x="868680" y="1965960"/>
+            <a:ext cx="4983480" cy="457200"/>
+          </a:xfrm>
+          <a:prstGeom prst="rect">
+            <a:avLst/>
+          </a:prstGeom>
+          <a:noFill/>
+        </p:spPr>
+        <p:txBody>
+          <a:bodyPr wrap="none">
+            <a:spAutoFit/>
+          </a:bodyPr>
+          <a:lstStyle/>
+          <a:p>
+            <a:r>
+              <a:rPr sz="2000" b="1">
+                <a:solidFill>
+                  <a:srgbClr val="12233F"/>
+                </a:solidFill>
+                <a:latin typeface="Calibri"/>
+              </a:rPr>
+              <a:t>Advisory + Operating Sprint</a:t>
+            </a:r>
+          </a:p>
+        </p:txBody>
+      </p:sp>
+      <p:sp>
+        <p:nvSpPr>
+          <p:cNvPr id="8" name="TextBox 7"/>
+          <p:cNvSpPr txBox="1"/>
+          <p:nvPr/>
+        </p:nvSpPr>
+        <p:spPr>
+          <a:xfrm>
+            <a:off x="868680" y="2514600"/>
+            <a:ext cx="4892040" cy="3749039"/>
           </a:xfrm>
           <a:prstGeom prst="rect">
             <a:avLst/>
@@ -3459,9 +3653,9 @@
           <a:p>
             <a:pPr>
               <a:spcAft>
-                <a:spcPts val="1400"/>
+                <a:spcPts val="1000"/>
               </a:spcAft>
-              <a:defRPr sz="2400">
+              <a:defRPr sz="1600">
                 <a:solidFill>
                   <a:srgbClr val="364559"/>
                 </a:solidFill>
@@ -3469,15 +3663,15 @@
               </a:defRPr>
             </a:pPr>
             <a:r>
-              <a:t>Global or regional beverage companies entering Southeast Asia.</a:t>
+              <a:t>30-90 day focused engagements for market entry, product launch, or supply chain redesign.</a:t>
             </a:r>
           </a:p>
           <a:p>
             <a:pPr>
               <a:spcAft>
-                <a:spcPts val="1400"/>
+                <a:spcPts val="1000"/>
               </a:spcAft>
-              <a:defRPr sz="2000">
+              <a:defRPr sz="1600">
                 <a:solidFill>
                   <a:srgbClr val="364559"/>
                 </a:solidFill>
@@ -3485,15 +3679,15 @@
               </a:defRPr>
             </a:pPr>
             <a:r>
-              <a:t>Established players needing stronger execution in Thailand, Vietnam, or Laos.</a:t>
+              <a:t>Workstreams: sourcing, plant partner selection, packaging readiness, pricing, and channel plan.</a:t>
             </a:r>
           </a:p>
           <a:p>
             <a:pPr>
               <a:spcAft>
-                <a:spcPts val="1400"/>
+                <a:spcPts val="1000"/>
               </a:spcAft>
-              <a:defRPr sz="2000">
+              <a:defRPr sz="1600">
                 <a:solidFill>
                   <a:srgbClr val="364559"/>
                 </a:solidFill>
@@ -3501,15 +3695,15 @@
               </a:defRPr>
             </a:pPr>
             <a:r>
-              <a:t>Teams expanding across beer, spirits, and RTD categories with shared infrastructure.</a:t>
+              <a:t>Weekly decision cadence with leadership team and execution owners.</a:t>
             </a:r>
           </a:p>
           <a:p>
             <a:pPr>
               <a:spcAft>
-                <a:spcPts val="1400"/>
+                <a:spcPts val="1000"/>
               </a:spcAft>
-              <a:defRPr sz="2000">
+              <a:defRPr sz="1600">
                 <a:solidFill>
                   <a:srgbClr val="364559"/>
                 </a:solidFill>
@@ -3517,7 +3711,128 @@
               </a:defRPr>
             </a:pPr>
             <a:r>
-              <a:t>Businesses seeking local operator credibility plus strategic clarity at executive level.</a:t>
+              <a:t>Output: clear operating playbook with accountability and rollout checkpoints.</a:t>
+            </a:r>
+          </a:p>
+        </p:txBody>
+      </p:sp>
+      <p:sp>
+        <p:nvSpPr>
+          <p:cNvPr id="9" name="TextBox 8"/>
+          <p:cNvSpPr txBox="1"/>
+          <p:nvPr/>
+        </p:nvSpPr>
+        <p:spPr>
+          <a:xfrm>
+            <a:off x="6355080" y="1965960"/>
+            <a:ext cx="4983480" cy="457200"/>
+          </a:xfrm>
+          <a:prstGeom prst="rect">
+            <a:avLst/>
+          </a:prstGeom>
+          <a:noFill/>
+        </p:spPr>
+        <p:txBody>
+          <a:bodyPr wrap="none">
+            <a:spAutoFit/>
+          </a:bodyPr>
+          <a:lstStyle/>
+          <a:p>
+            <a:r>
+              <a:rPr sz="2000" b="1">
+                <a:solidFill>
+                  <a:srgbClr val="12233F"/>
+                </a:solidFill>
+                <a:latin typeface="Calibri"/>
+              </a:rPr>
+              <a:t>Fractional NPD Leadership</a:t>
+            </a:r>
+          </a:p>
+        </p:txBody>
+      </p:sp>
+      <p:sp>
+        <p:nvSpPr>
+          <p:cNvPr id="10" name="TextBox 9"/>
+          <p:cNvSpPr txBox="1"/>
+          <p:nvPr/>
+        </p:nvSpPr>
+        <p:spPr>
+          <a:xfrm>
+            <a:off x="6355080" y="2514600"/>
+            <a:ext cx="4892040" cy="3749039"/>
+          </a:xfrm>
+          <a:prstGeom prst="rect">
+            <a:avLst/>
+          </a:prstGeom>
+          <a:noFill/>
+        </p:spPr>
+        <p:txBody>
+          <a:bodyPr wrap="square">
+            <a:spAutoFit/>
+          </a:bodyPr>
+          <a:lstStyle/>
+          <a:p>
+            <a:pPr>
+              <a:spcAft>
+                <a:spcPts val="1000"/>
+              </a:spcAft>
+              <a:defRPr sz="1600">
+                <a:solidFill>
+                  <a:srgbClr val="364559"/>
+                </a:solidFill>
+                <a:latin typeface="Calibri"/>
+              </a:defRPr>
+            </a:pPr>
+            <a:r>
+              <a:t>Embedded support for teams that need senior NPD and commercialization leadership.</a:t>
+            </a:r>
+          </a:p>
+          <a:p>
+            <a:pPr>
+              <a:spcAft>
+                <a:spcPts val="1000"/>
+              </a:spcAft>
+              <a:defRPr sz="1600">
+                <a:solidFill>
+                  <a:srgbClr val="364559"/>
+                </a:solidFill>
+                <a:latin typeface="Calibri"/>
+              </a:defRPr>
+            </a:pPr>
+            <a:r>
+              <a:t>Cross-functional bridge between procurement, operations, marketing, and sales.</a:t>
+            </a:r>
+          </a:p>
+          <a:p>
+            <a:pPr>
+              <a:spcAft>
+                <a:spcPts val="1000"/>
+              </a:spcAft>
+              <a:defRPr sz="1600">
+                <a:solidFill>
+                  <a:srgbClr val="364559"/>
+                </a:solidFill>
+                <a:latin typeface="Calibri"/>
+              </a:defRPr>
+            </a:pPr>
+            <a:r>
+              <a:t>Focus on profitable scale, not just innovation theater.</a:t>
+            </a:r>
+          </a:p>
+          <a:p>
+            <a:pPr>
+              <a:spcAft>
+                <a:spcPts val="1000"/>
+              </a:spcAft>
+              <a:defRPr sz="1600">
+                <a:solidFill>
+                  <a:srgbClr val="364559"/>
+                </a:solidFill>
+                <a:latin typeface="Calibri"/>
+              </a:defRPr>
+            </a:pPr>
+            <a:r>
+              <a:t>Output: repeatable launch process that compounds over multiple product cycles.</a:t>
             </a:r>
           </a:p>
         </p:txBody>
@@ -3630,6 +3945,240 @@
                 </a:solidFill>
                 <a:latin typeface="Calibri"/>
               </a:rPr>
+              <a:t>Ideal Clients</a:t>
+            </a:r>
+          </a:p>
+        </p:txBody>
+      </p:sp>
+      <p:sp>
+        <p:nvSpPr>
+          <p:cNvPr id="4" name="TextBox 3"/>
+          <p:cNvSpPr txBox="1"/>
+          <p:nvPr/>
+        </p:nvSpPr>
+        <p:spPr>
+          <a:xfrm>
+            <a:off x="640080" y="822960"/>
+            <a:ext cx="11064240" cy="731520"/>
+          </a:xfrm>
+          <a:prstGeom prst="rect">
+            <a:avLst/>
+          </a:prstGeom>
+          <a:noFill/>
+        </p:spPr>
+        <p:txBody>
+          <a:bodyPr wrap="none">
+            <a:spAutoFit/>
+          </a:bodyPr>
+          <a:lstStyle/>
+          <a:p>
+            <a:r>
+              <a:rPr sz="3400" b="1">
+                <a:solidFill>
+                  <a:srgbClr val="12233F"/>
+                </a:solidFill>
+                <a:latin typeface="Calibri"/>
+              </a:rPr>
+              <a:t>Best Fit Engagements</a:t>
+            </a:r>
+          </a:p>
+        </p:txBody>
+      </p:sp>
+      <p:sp>
+        <p:nvSpPr>
+          <p:cNvPr id="5" name="TextBox 4"/>
+          <p:cNvSpPr txBox="1"/>
+          <p:nvPr/>
+        </p:nvSpPr>
+        <p:spPr>
+          <a:xfrm>
+            <a:off x="868680" y="1645920"/>
+            <a:ext cx="10789920" cy="4480560"/>
+          </a:xfrm>
+          <a:prstGeom prst="rect">
+            <a:avLst/>
+          </a:prstGeom>
+          <a:noFill/>
+        </p:spPr>
+        <p:txBody>
+          <a:bodyPr wrap="square">
+            <a:spAutoFit/>
+          </a:bodyPr>
+          <a:lstStyle/>
+          <a:p>
+            <a:pPr>
+              <a:spcAft>
+                <a:spcPts val="1400"/>
+              </a:spcAft>
+              <a:defRPr sz="2400">
+                <a:solidFill>
+                  <a:srgbClr val="364559"/>
+                </a:solidFill>
+                <a:latin typeface="Calibri"/>
+              </a:defRPr>
+            </a:pPr>
+            <a:r>
+              <a:t>Global or regional beverage companies entering Southeast Asia.</a:t>
+            </a:r>
+          </a:p>
+          <a:p>
+            <a:pPr>
+              <a:spcAft>
+                <a:spcPts val="1400"/>
+              </a:spcAft>
+              <a:defRPr sz="2000">
+                <a:solidFill>
+                  <a:srgbClr val="364559"/>
+                </a:solidFill>
+                <a:latin typeface="Calibri"/>
+              </a:defRPr>
+            </a:pPr>
+            <a:r>
+              <a:t>Established players needing stronger execution in Thailand, Vietnam, or Laos.</a:t>
+            </a:r>
+          </a:p>
+          <a:p>
+            <a:pPr>
+              <a:spcAft>
+                <a:spcPts val="1400"/>
+              </a:spcAft>
+              <a:defRPr sz="2000">
+                <a:solidFill>
+                  <a:srgbClr val="364559"/>
+                </a:solidFill>
+                <a:latin typeface="Calibri"/>
+              </a:defRPr>
+            </a:pPr>
+            <a:r>
+              <a:t>Teams expanding across beer, spirits, and RTD categories with shared infrastructure.</a:t>
+            </a:r>
+          </a:p>
+          <a:p>
+            <a:pPr>
+              <a:spcAft>
+                <a:spcPts val="1400"/>
+              </a:spcAft>
+              <a:defRPr sz="2000">
+                <a:solidFill>
+                  <a:srgbClr val="364559"/>
+                </a:solidFill>
+                <a:latin typeface="Calibri"/>
+              </a:defRPr>
+            </a:pPr>
+            <a:r>
+              <a:t>Businesses seeking local operator credibility plus strategic clarity at executive level.</a:t>
+            </a:r>
+          </a:p>
+        </p:txBody>
+      </p:sp>
+    </p:spTree>
+  </p:cSld>
+  <p:clrMapOvr>
+    <a:masterClrMapping/>
+  </p:clrMapOvr>
+</p:sld>
+</file>
+
+<file path=ppt/slides/slide12.xml><?xml version="1.0" encoding="utf-8"?>
+<p:sld xmlns:a="http://schemas.openxmlformats.org/drawingml/2006/main" xmlns:p="http://schemas.openxmlformats.org/presentationml/2006/main" xmlns:r="http://schemas.openxmlformats.org/officeDocument/2006/relationships">
+  <p:cSld>
+    <p:spTree>
+      <p:nvGrpSpPr>
+        <p:cNvPr id="1" name=""/>
+        <p:cNvGrpSpPr/>
+        <p:nvPr/>
+      </p:nvGrpSpPr>
+      <p:grpSpPr/>
+      <p:sp>
+        <p:nvSpPr>
+          <p:cNvPr id="2" name="Rectangle 1"/>
+          <p:cNvSpPr/>
+          <p:nvPr/>
+        </p:nvSpPr>
+        <p:spPr>
+          <a:xfrm>
+            <a:off x="0" y="0"/>
+            <a:ext cx="12188952" cy="6858000"/>
+          </a:xfrm>
+          <a:prstGeom prst="rect">
+            <a:avLst/>
+          </a:prstGeom>
+          <a:solidFill>
+            <a:srgbClr val="F7F9FC"/>
+          </a:solidFill>
+          <a:ln>
+            <a:noFill/>
+          </a:ln>
+        </p:spPr>
+        <p:style>
+          <a:lnRef idx="1">
+            <a:schemeClr val="accent1"/>
+          </a:lnRef>
+          <a:fillRef idx="3">
+            <a:schemeClr val="accent1"/>
+          </a:fillRef>
+          <a:effectRef idx="2">
+            <a:schemeClr val="accent1"/>
+          </a:effectRef>
+          <a:fontRef idx="minor">
+            <a:schemeClr val="lt1"/>
+          </a:fontRef>
+        </p:style>
+        <p:txBody>
+          <a:bodyPr rtlCol="0" anchor="ctr"/>
+          <a:lstStyle/>
+          <a:p>
+            <a:pPr algn="ctr"/>
+          </a:p>
+        </p:txBody>
+      </p:sp>
+      <p:sp>
+        <p:nvSpPr>
+          <p:cNvPr id="3" name="Rectangle 2"/>
+          <p:cNvSpPr/>
+          <p:nvPr/>
+        </p:nvSpPr>
+        <p:spPr>
+          <a:xfrm>
+            <a:off x="0" y="0"/>
+            <a:ext cx="12188952" cy="502920"/>
+          </a:xfrm>
+          <a:prstGeom prst="rect">
+            <a:avLst/>
+          </a:prstGeom>
+          <a:solidFill>
+            <a:srgbClr val="12233F"/>
+          </a:solidFill>
+          <a:ln>
+            <a:noFill/>
+          </a:ln>
+        </p:spPr>
+        <p:style>
+          <a:lnRef idx="1">
+            <a:schemeClr val="accent1"/>
+          </a:lnRef>
+          <a:fillRef idx="3">
+            <a:schemeClr val="accent1"/>
+          </a:fillRef>
+          <a:effectRef idx="2">
+            <a:schemeClr val="accent1"/>
+          </a:effectRef>
+          <a:fontRef idx="minor">
+            <a:schemeClr val="lt1"/>
+          </a:fontRef>
+        </p:style>
+        <p:txBody>
+          <a:bodyPr rtlCol="0" anchor="ctr" lIns="228600"/>
+          <a:lstStyle/>
+          <a:p>
+            <a:pPr algn="l"/>
+            <a:r>
+              <a:rPr sz="1600" b="1">
+                <a:solidFill>
+                  <a:srgbClr val="FFFFFF"/>
+                </a:solidFill>
+                <a:latin typeface="Calibri"/>
+              </a:rPr>
               <a:t>Contact</a:t>
             </a:r>
           </a:p>
@@ -4502,7 +5051,7 @@
                 </a:solidFill>
                 <a:latin typeface="Calibri"/>
               </a:rPr>
-              <a:t>Global Supply Chain</a:t>
+              <a:t>Brand + Concepts</a:t>
             </a:r>
           </a:p>
         </p:txBody>
@@ -4516,7 +5065,7 @@
         <p:spPr>
           <a:xfrm>
             <a:off x="640080" y="822960"/>
-            <a:ext cx="11064240" cy="731520"/>
+            <a:ext cx="8503920" cy="731520"/>
           </a:xfrm>
           <a:prstGeom prst="rect">
             <a:avLst/>
@@ -4530,13 +5079,13 @@
           <a:lstStyle/>
           <a:p>
             <a:r>
-              <a:rPr sz="3400" b="1">
+              <a:rPr sz="3000" b="1">
                 <a:solidFill>
                   <a:srgbClr val="12233F"/>
                 </a:solidFill>
                 <a:latin typeface="Calibri"/>
               </a:rPr>
-              <a:t>Hyper-Specific Operating Model: Source Global, Produce Local, Sell Regional</a:t>
+              <a:t>Mahanakhon Brand Identity + Product Concepts</a:t>
             </a:r>
           </a:p>
         </p:txBody>
@@ -4549,8 +5098,8 @@
         </p:nvSpPr>
         <p:spPr>
           <a:xfrm>
-            <a:off x="868680" y="1645920"/>
-            <a:ext cx="10789920" cy="4480560"/>
+            <a:off x="640080" y="1325880"/>
+            <a:ext cx="8869680" cy="411480"/>
           </a:xfrm>
           <a:prstGeom prst="rect">
             <a:avLst/>
@@ -4558,88 +5107,19 @@
           <a:noFill/>
         </p:spPr>
         <p:txBody>
-          <a:bodyPr wrap="square">
+          <a:bodyPr wrap="none">
             <a:spAutoFit/>
           </a:bodyPr>
           <a:lstStyle/>
           <a:p>
-            <a:pPr>
-              <a:spcAft>
-                <a:spcPts val="1400"/>
-              </a:spcAft>
-              <a:defRPr sz="2400">
+            <a:r>
+              <a:rPr sz="1400">
                 <a:solidFill>
                   <a:srgbClr val="364559"/>
                 </a:solidFill>
                 <a:latin typeface="Calibri"/>
-              </a:defRPr>
-            </a:pPr>
-            <a:r>
-              <a:t>Raw materials: hop procurement from the USA and New Zealand with quality/spec alignment and cost controls.</a:t>
-            </a:r>
-          </a:p>
-          <a:p>
-            <a:pPr>
-              <a:spcAft>
-                <a:spcPts val="1400"/>
-              </a:spcAft>
-              <a:defRPr sz="2000">
-                <a:solidFill>
-                  <a:srgbClr val="364559"/>
-                </a:solidFill>
-                <a:latin typeface="Calibri"/>
-              </a:defRPr>
-            </a:pPr>
-            <a:r>
-              <a:t>Production backbone: partner plants in Vietnam and Thailand across Brewery, Distillery, and RTD categories.</a:t>
-            </a:r>
-          </a:p>
-          <a:p>
-            <a:pPr>
-              <a:spcAft>
-                <a:spcPts val="1400"/>
-              </a:spcAft>
-              <a:defRPr sz="2000">
-                <a:solidFill>
-                  <a:srgbClr val="364559"/>
-                </a:solidFill>
-                <a:latin typeface="Calibri"/>
-              </a:defRPr>
-            </a:pPr>
-            <a:r>
-              <a:t>Packaging network: coordinated can, bottle, closure, and label suppliers to protect lead time and cash flow.</a:t>
-            </a:r>
-          </a:p>
-          <a:p>
-            <a:pPr>
-              <a:spcAft>
-                <a:spcPts val="1400"/>
-              </a:spcAft>
-              <a:defRPr sz="2000">
-                <a:solidFill>
-                  <a:srgbClr val="364559"/>
-                </a:solidFill>
-                <a:latin typeface="Calibri"/>
-              </a:defRPr>
-            </a:pPr>
-            <a:r>
-              <a:t>Regional flow: finished goods exported to convenience store channels in Taiwan and Japan.</a:t>
-            </a:r>
-          </a:p>
-          <a:p>
-            <a:pPr>
-              <a:spcAft>
-                <a:spcPts val="1400"/>
-              </a:spcAft>
-              <a:defRPr sz="2000">
-                <a:solidFill>
-                  <a:srgbClr val="364559"/>
-                </a:solidFill>
-                <a:latin typeface="Calibri"/>
-              </a:defRPr>
-            </a:pPr>
-            <a:r>
-              <a:t>Market expansion support: launch blueprints for clients opening new beverage markets in Laos.</a:t>
+              </a:rPr>
+              <a:t>Integrates the sourced Mahanakhon logo and concept-ready product visual placements.</a:t>
             </a:r>
           </a:p>
         </p:txBody>
@@ -4652,17 +5132,19 @@
         </p:nvSpPr>
         <p:spPr>
           <a:xfrm>
-            <a:off x="868680" y="6035040"/>
-            <a:ext cx="10789920" cy="27432"/>
+            <a:off x="9464040" y="658368"/>
+            <a:ext cx="2057400" cy="1078992"/>
           </a:xfrm>
           <a:prstGeom prst="rect">
             <a:avLst/>
           </a:prstGeom>
           <a:solidFill>
-            <a:srgbClr val="C79948"/>
+            <a:srgbClr val="FFFFFF"/>
           </a:solidFill>
           <a:ln>
-            <a:noFill/>
+            <a:solidFill>
+              <a:srgbClr val="D8DFE8"/>
+            </a:solidFill>
           </a:ln>
         </p:spPr>
         <p:style>
@@ -4687,16 +5169,147 @@
           </a:p>
         </p:txBody>
       </p:sp>
-      <p:sp>
-        <p:nvSpPr>
-          <p:cNvPr id="7" name="TextBox 6"/>
+      <p:pic>
+        <p:nvPicPr>
+          <p:cNvPr id="7" name="Picture 6" descr="mahanakhon-brewery-logo-hd.jpeg"/>
+          <p:cNvPicPr>
+            <a:picLocks noChangeAspect="1"/>
+          </p:cNvPicPr>
+          <p:nvPr/>
+        </p:nvPicPr>
+        <p:blipFill>
+          <a:blip r:embed="rId2"/>
+          <a:stretch>
+            <a:fillRect/>
+          </a:stretch>
+        </p:blipFill>
+        <p:spPr>
+          <a:xfrm>
+            <a:off x="9573768" y="722376"/>
+            <a:ext cx="1828800" cy="786384"/>
+          </a:xfrm>
+          <a:prstGeom prst="rect">
+            <a:avLst/>
+          </a:prstGeom>
+        </p:spPr>
+      </p:pic>
+      <p:sp>
+        <p:nvSpPr>
+          <p:cNvPr id="8" name="Rectangle 7"/>
+          <p:cNvSpPr/>
+          <p:nvPr/>
+        </p:nvSpPr>
+        <p:spPr>
+          <a:xfrm>
+            <a:off x="640080" y="1828800"/>
+            <a:ext cx="3703320" cy="4526280"/>
+          </a:xfrm>
+          <a:prstGeom prst="rect">
+            <a:avLst/>
+          </a:prstGeom>
+          <a:solidFill>
+            <a:srgbClr val="FFFFFF"/>
+          </a:solidFill>
+          <a:ln>
+            <a:solidFill>
+              <a:srgbClr val="D8DFE8"/>
+            </a:solidFill>
+          </a:ln>
+        </p:spPr>
+        <p:style>
+          <a:lnRef idx="1">
+            <a:schemeClr val="accent1"/>
+          </a:lnRef>
+          <a:fillRef idx="3">
+            <a:schemeClr val="accent1"/>
+          </a:fillRef>
+          <a:effectRef idx="2">
+            <a:schemeClr val="accent1"/>
+          </a:effectRef>
+          <a:fontRef idx="minor">
+            <a:schemeClr val="lt1"/>
+          </a:fontRef>
+        </p:style>
+        <p:txBody>
+          <a:bodyPr rtlCol="0" anchor="ctr"/>
+          <a:lstStyle/>
+          <a:p>
+            <a:pPr algn="ctr"/>
+          </a:p>
+        </p:txBody>
+      </p:sp>
+      <p:sp>
+        <p:nvSpPr>
+          <p:cNvPr id="9" name="Rectangle 8"/>
+          <p:cNvSpPr/>
+          <p:nvPr/>
+        </p:nvSpPr>
+        <p:spPr>
+          <a:xfrm>
+            <a:off x="804671" y="2011680"/>
+            <a:ext cx="3374136" cy="3566160"/>
+          </a:xfrm>
+          <a:prstGeom prst="rect">
+            <a:avLst/>
+          </a:prstGeom>
+          <a:solidFill>
+            <a:srgbClr val="E8EDF4"/>
+          </a:solidFill>
+          <a:ln>
+            <a:noFill/>
+          </a:ln>
+        </p:spPr>
+        <p:style>
+          <a:lnRef idx="1">
+            <a:schemeClr val="accent1"/>
+          </a:lnRef>
+          <a:fillRef idx="3">
+            <a:schemeClr val="accent1"/>
+          </a:fillRef>
+          <a:effectRef idx="2">
+            <a:schemeClr val="accent1"/>
+          </a:effectRef>
+          <a:fontRef idx="minor">
+            <a:schemeClr val="lt1"/>
+          </a:fontRef>
+        </p:style>
+        <p:txBody>
+          <a:bodyPr rtlCol="0" anchor="ctr"/>
+          <a:lstStyle/>
+          <a:p>
+            <a:pPr algn="ctr">
+              <a:defRPr sz="1200">
+                <a:solidFill>
+                  <a:srgbClr val="364559"/>
+                </a:solidFill>
+                <a:latin typeface="Calibri"/>
+              </a:defRPr>
+            </a:pPr>
+            <a:r>
+              <a:t>Concept image placeholder</a:t>
+            </a:r>
+            <a:br/>
+            <a:br/>
+            <a:r>
+              <a:t>Add one file:</a:t>
+            </a:r>
+            <a:br/>
+            <a:r>
+              <a:t>assets/concepts/phanya-laos-sour-mash-whiskey.jpg|jpeg|png|webp</a:t>
+            </a:r>
+          </a:p>
+        </p:txBody>
+      </p:sp>
+      <p:sp>
+        <p:nvSpPr>
+          <p:cNvPr id="10" name="TextBox 9"/>
           <p:cNvSpPr txBox="1"/>
           <p:nvPr/>
         </p:nvSpPr>
         <p:spPr>
           <a:xfrm>
-            <a:off x="868680" y="6144768"/>
-            <a:ext cx="10789920" cy="548640"/>
+            <a:off x="804671" y="5532120"/>
+            <a:ext cx="3374136" cy="731520"/>
           </a:xfrm>
           <a:prstGeom prst="rect">
             <a:avLst/>
@@ -4709,14 +5322,338 @@
           </a:bodyPr>
           <a:lstStyle/>
           <a:p>
-            <a:r>
-              <a:rPr sz="1400">
+            <a:pPr algn="ctr"/>
+            <a:r>
+              <a:rPr sz="1600" b="1">
+                <a:solidFill>
+                  <a:srgbClr val="12233F"/>
+                </a:solidFill>
+                <a:latin typeface="Calibri"/>
+              </a:rPr>
+              <a:t>PHANYA</a:t>
+            </a:r>
+          </a:p>
+          <a:p>
+            <a:pPr algn="ctr">
+              <a:defRPr sz="1200">
                 <a:solidFill>
                   <a:srgbClr val="364559"/>
                 </a:solidFill>
                 <a:latin typeface="Calibri"/>
+              </a:defRPr>
+            </a:pPr>
+            <a:r>
+              <a:t>Laos Sour Mash Whiskey</a:t>
+            </a:r>
+          </a:p>
+        </p:txBody>
+      </p:sp>
+      <p:sp>
+        <p:nvSpPr>
+          <p:cNvPr id="11" name="Rectangle 10"/>
+          <p:cNvSpPr/>
+          <p:nvPr/>
+        </p:nvSpPr>
+        <p:spPr>
+          <a:xfrm>
+            <a:off x="4242816" y="1828800"/>
+            <a:ext cx="3703320" cy="4526280"/>
+          </a:xfrm>
+          <a:prstGeom prst="rect">
+            <a:avLst/>
+          </a:prstGeom>
+          <a:solidFill>
+            <a:srgbClr val="FFFFFF"/>
+          </a:solidFill>
+          <a:ln>
+            <a:solidFill>
+              <a:srgbClr val="D8DFE8"/>
+            </a:solidFill>
+          </a:ln>
+        </p:spPr>
+        <p:style>
+          <a:lnRef idx="1">
+            <a:schemeClr val="accent1"/>
+          </a:lnRef>
+          <a:fillRef idx="3">
+            <a:schemeClr val="accent1"/>
+          </a:fillRef>
+          <a:effectRef idx="2">
+            <a:schemeClr val="accent1"/>
+          </a:effectRef>
+          <a:fontRef idx="minor">
+            <a:schemeClr val="lt1"/>
+          </a:fontRef>
+        </p:style>
+        <p:txBody>
+          <a:bodyPr rtlCol="0" anchor="ctr"/>
+          <a:lstStyle/>
+          <a:p>
+            <a:pPr algn="ctr"/>
+          </a:p>
+        </p:txBody>
+      </p:sp>
+      <p:sp>
+        <p:nvSpPr>
+          <p:cNvPr id="12" name="Rectangle 11"/>
+          <p:cNvSpPr/>
+          <p:nvPr/>
+        </p:nvSpPr>
+        <p:spPr>
+          <a:xfrm>
+            <a:off x="4407407" y="2011680"/>
+            <a:ext cx="3374136" cy="3566160"/>
+          </a:xfrm>
+          <a:prstGeom prst="rect">
+            <a:avLst/>
+          </a:prstGeom>
+          <a:solidFill>
+            <a:srgbClr val="E8EDF4"/>
+          </a:solidFill>
+          <a:ln>
+            <a:noFill/>
+          </a:ln>
+        </p:spPr>
+        <p:style>
+          <a:lnRef idx="1">
+            <a:schemeClr val="accent1"/>
+          </a:lnRef>
+          <a:fillRef idx="3">
+            <a:schemeClr val="accent1"/>
+          </a:fillRef>
+          <a:effectRef idx="2">
+            <a:schemeClr val="accent1"/>
+          </a:effectRef>
+          <a:fontRef idx="minor">
+            <a:schemeClr val="lt1"/>
+          </a:fontRef>
+        </p:style>
+        <p:txBody>
+          <a:bodyPr rtlCol="0" anchor="ctr"/>
+          <a:lstStyle/>
+          <a:p>
+            <a:pPr algn="ctr">
+              <a:defRPr sz="1200">
+                <a:solidFill>
+                  <a:srgbClr val="364559"/>
+                </a:solidFill>
+                <a:latin typeface="Calibri"/>
+              </a:defRPr>
+            </a:pPr>
+            <a:r>
+              <a:t>Concept image placeholder</a:t>
+            </a:r>
+            <a:br/>
+            <a:br/>
+            <a:r>
+              <a:t>Add one file:</a:t>
+            </a:r>
+            <a:br/>
+            <a:r>
+              <a:t>assets/concepts/two-palms-tropical-hazy-ipa.jpg|jpeg|png|webp</a:t>
+            </a:r>
+          </a:p>
+        </p:txBody>
+      </p:sp>
+      <p:sp>
+        <p:nvSpPr>
+          <p:cNvPr id="13" name="TextBox 12"/>
+          <p:cNvSpPr txBox="1"/>
+          <p:nvPr/>
+        </p:nvSpPr>
+        <p:spPr>
+          <a:xfrm>
+            <a:off x="4407407" y="5532120"/>
+            <a:ext cx="3374136" cy="731520"/>
+          </a:xfrm>
+          <a:prstGeom prst="rect">
+            <a:avLst/>
+          </a:prstGeom>
+          <a:noFill/>
+        </p:spPr>
+        <p:txBody>
+          <a:bodyPr wrap="none">
+            <a:spAutoFit/>
+          </a:bodyPr>
+          <a:lstStyle/>
+          <a:p>
+            <a:pPr algn="ctr"/>
+            <a:r>
+              <a:rPr sz="1600" b="1">
+                <a:solidFill>
+                  <a:srgbClr val="12233F"/>
+                </a:solidFill>
+                <a:latin typeface="Calibri"/>
               </a:rPr>
-              <a:t>Result: diversified supply continuity with practical production optionality across countries and categories.</a:t>
+              <a:t>TWO PALMS HAZY</a:t>
+            </a:r>
+          </a:p>
+          <a:p>
+            <a:pPr algn="ctr">
+              <a:defRPr sz="1200">
+                <a:solidFill>
+                  <a:srgbClr val="364559"/>
+                </a:solidFill>
+                <a:latin typeface="Calibri"/>
+              </a:defRPr>
+            </a:pPr>
+            <a:r>
+              <a:t>Tropical Hazy IPA</a:t>
+            </a:r>
+          </a:p>
+        </p:txBody>
+      </p:sp>
+      <p:sp>
+        <p:nvSpPr>
+          <p:cNvPr id="14" name="Rectangle 13"/>
+          <p:cNvSpPr/>
+          <p:nvPr/>
+        </p:nvSpPr>
+        <p:spPr>
+          <a:xfrm>
+            <a:off x="7845552" y="1828800"/>
+            <a:ext cx="3703320" cy="4526280"/>
+          </a:xfrm>
+          <a:prstGeom prst="rect">
+            <a:avLst/>
+          </a:prstGeom>
+          <a:solidFill>
+            <a:srgbClr val="FFFFFF"/>
+          </a:solidFill>
+          <a:ln>
+            <a:solidFill>
+              <a:srgbClr val="D8DFE8"/>
+            </a:solidFill>
+          </a:ln>
+        </p:spPr>
+        <p:style>
+          <a:lnRef idx="1">
+            <a:schemeClr val="accent1"/>
+          </a:lnRef>
+          <a:fillRef idx="3">
+            <a:schemeClr val="accent1"/>
+          </a:fillRef>
+          <a:effectRef idx="2">
+            <a:schemeClr val="accent1"/>
+          </a:effectRef>
+          <a:fontRef idx="minor">
+            <a:schemeClr val="lt1"/>
+          </a:fontRef>
+        </p:style>
+        <p:txBody>
+          <a:bodyPr rtlCol="0" anchor="ctr"/>
+          <a:lstStyle/>
+          <a:p>
+            <a:pPr algn="ctr"/>
+          </a:p>
+        </p:txBody>
+      </p:sp>
+      <p:sp>
+        <p:nvSpPr>
+          <p:cNvPr id="15" name="Rectangle 14"/>
+          <p:cNvSpPr/>
+          <p:nvPr/>
+        </p:nvSpPr>
+        <p:spPr>
+          <a:xfrm>
+            <a:off x="8010144" y="2011680"/>
+            <a:ext cx="3374136" cy="3566160"/>
+          </a:xfrm>
+          <a:prstGeom prst="rect">
+            <a:avLst/>
+          </a:prstGeom>
+          <a:solidFill>
+            <a:srgbClr val="E8EDF4"/>
+          </a:solidFill>
+          <a:ln>
+            <a:noFill/>
+          </a:ln>
+        </p:spPr>
+        <p:style>
+          <a:lnRef idx="1">
+            <a:schemeClr val="accent1"/>
+          </a:lnRef>
+          <a:fillRef idx="3">
+            <a:schemeClr val="accent1"/>
+          </a:fillRef>
+          <a:effectRef idx="2">
+            <a:schemeClr val="accent1"/>
+          </a:effectRef>
+          <a:fontRef idx="minor">
+            <a:schemeClr val="lt1"/>
+          </a:fontRef>
+        </p:style>
+        <p:txBody>
+          <a:bodyPr rtlCol="0" anchor="ctr"/>
+          <a:lstStyle/>
+          <a:p>
+            <a:pPr algn="ctr">
+              <a:defRPr sz="1200">
+                <a:solidFill>
+                  <a:srgbClr val="364559"/>
+                </a:solidFill>
+                <a:latin typeface="Calibri"/>
+              </a:defRPr>
+            </a:pPr>
+            <a:r>
+              <a:t>Concept image placeholder</a:t>
+            </a:r>
+            <a:br/>
+            <a:br/>
+            <a:r>
+              <a:t>Add one file:</a:t>
+            </a:r>
+            <a:br/>
+            <a:r>
+              <a:t>assets/concepts/shimapan-highball-club.jpg|jpeg|png|webp</a:t>
+            </a:r>
+          </a:p>
+        </p:txBody>
+      </p:sp>
+      <p:sp>
+        <p:nvSpPr>
+          <p:cNvPr id="16" name="TextBox 15"/>
+          <p:cNvSpPr txBox="1"/>
+          <p:nvPr/>
+        </p:nvSpPr>
+        <p:spPr>
+          <a:xfrm>
+            <a:off x="8010144" y="5532120"/>
+            <a:ext cx="3374136" cy="731520"/>
+          </a:xfrm>
+          <a:prstGeom prst="rect">
+            <a:avLst/>
+          </a:prstGeom>
+          <a:noFill/>
+        </p:spPr>
+        <p:txBody>
+          <a:bodyPr wrap="none">
+            <a:spAutoFit/>
+          </a:bodyPr>
+          <a:lstStyle/>
+          <a:p>
+            <a:pPr algn="ctr"/>
+            <a:r>
+              <a:rPr sz="1600" b="1">
+                <a:solidFill>
+                  <a:srgbClr val="12233F"/>
+                </a:solidFill>
+                <a:latin typeface="Calibri"/>
+              </a:rPr>
+              <a:t>SHIMAPAN</a:t>
+            </a:r>
+          </a:p>
+          <a:p>
+            <a:pPr algn="ctr">
+              <a:defRPr sz="1200">
+                <a:solidFill>
+                  <a:srgbClr val="364559"/>
+                </a:solidFill>
+                <a:latin typeface="Calibri"/>
+              </a:defRPr>
+            </a:pPr>
+            <a:r>
+              <a:t>Highball Club</a:t>
             </a:r>
           </a:p>
         </p:txBody>
@@ -4829,7 +5766,7 @@
                 </a:solidFill>
                 <a:latin typeface="Calibri"/>
               </a:rPr>
-              <a:t>Regional Commercialization</a:t>
+              <a:t>Global Supply Chain</a:t>
             </a:r>
           </a:p>
         </p:txBody>
@@ -4857,38 +5794,139 @@
           <a:lstStyle/>
           <a:p>
             <a:r>
-              <a:rPr sz="3000" b="1">
+              <a:rPr sz="3400" b="1">
                 <a:solidFill>
                   <a:srgbClr val="12233F"/>
                 </a:solidFill>
                 <a:latin typeface="Calibri"/>
               </a:rPr>
-              <a:t>Route-to-Market and Pricing Strategy by Market</a:t>
-            </a:r>
-          </a:p>
-        </p:txBody>
-      </p:sp>
-      <p:sp>
-        <p:nvSpPr>
-          <p:cNvPr id="5" name="Rectangle 4"/>
+              <a:t>Hyper-Specific Operating Model: Source Global, Produce Local, Sell Regional</a:t>
+            </a:r>
+          </a:p>
+        </p:txBody>
+      </p:sp>
+      <p:sp>
+        <p:nvSpPr>
+          <p:cNvPr id="5" name="TextBox 4"/>
+          <p:cNvSpPr txBox="1"/>
+          <p:nvPr/>
+        </p:nvSpPr>
+        <p:spPr>
+          <a:xfrm>
+            <a:off x="868680" y="1645920"/>
+            <a:ext cx="10789920" cy="4480560"/>
+          </a:xfrm>
+          <a:prstGeom prst="rect">
+            <a:avLst/>
+          </a:prstGeom>
+          <a:noFill/>
+        </p:spPr>
+        <p:txBody>
+          <a:bodyPr wrap="square">
+            <a:spAutoFit/>
+          </a:bodyPr>
+          <a:lstStyle/>
+          <a:p>
+            <a:pPr>
+              <a:spcAft>
+                <a:spcPts val="1400"/>
+              </a:spcAft>
+              <a:defRPr sz="2400">
+                <a:solidFill>
+                  <a:srgbClr val="364559"/>
+                </a:solidFill>
+                <a:latin typeface="Calibri"/>
+              </a:defRPr>
+            </a:pPr>
+            <a:r>
+              <a:t>Raw materials: hop procurement from the USA and New Zealand with quality/spec alignment and cost controls.</a:t>
+            </a:r>
+          </a:p>
+          <a:p>
+            <a:pPr>
+              <a:spcAft>
+                <a:spcPts val="1400"/>
+              </a:spcAft>
+              <a:defRPr sz="2000">
+                <a:solidFill>
+                  <a:srgbClr val="364559"/>
+                </a:solidFill>
+                <a:latin typeface="Calibri"/>
+              </a:defRPr>
+            </a:pPr>
+            <a:r>
+              <a:t>Production backbone: partner plants in Vietnam and Thailand across Brewery, Distillery, and RTD categories.</a:t>
+            </a:r>
+          </a:p>
+          <a:p>
+            <a:pPr>
+              <a:spcAft>
+                <a:spcPts val="1400"/>
+              </a:spcAft>
+              <a:defRPr sz="2000">
+                <a:solidFill>
+                  <a:srgbClr val="364559"/>
+                </a:solidFill>
+                <a:latin typeface="Calibri"/>
+              </a:defRPr>
+            </a:pPr>
+            <a:r>
+              <a:t>Packaging network: coordinated can, bottle, closure, and label suppliers to protect lead time and cash flow.</a:t>
+            </a:r>
+          </a:p>
+          <a:p>
+            <a:pPr>
+              <a:spcAft>
+                <a:spcPts val="1400"/>
+              </a:spcAft>
+              <a:defRPr sz="2000">
+                <a:solidFill>
+                  <a:srgbClr val="364559"/>
+                </a:solidFill>
+                <a:latin typeface="Calibri"/>
+              </a:defRPr>
+            </a:pPr>
+            <a:r>
+              <a:t>Regional flow: finished goods exported to convenience store channels in Taiwan and Japan.</a:t>
+            </a:r>
+          </a:p>
+          <a:p>
+            <a:pPr>
+              <a:spcAft>
+                <a:spcPts val="1400"/>
+              </a:spcAft>
+              <a:defRPr sz="2000">
+                <a:solidFill>
+                  <a:srgbClr val="364559"/>
+                </a:solidFill>
+                <a:latin typeface="Calibri"/>
+              </a:defRPr>
+            </a:pPr>
+            <a:r>
+              <a:t>Market expansion support: launch blueprints for clients opening new beverage markets in Laos.</a:t>
+            </a:r>
+          </a:p>
+        </p:txBody>
+      </p:sp>
+      <p:sp>
+        <p:nvSpPr>
+          <p:cNvPr id="6" name="Rectangle 5"/>
           <p:cNvSpPr/>
           <p:nvPr/>
         </p:nvSpPr>
         <p:spPr>
           <a:xfrm>
-            <a:off x="640080" y="1737360"/>
-            <a:ext cx="5440680" cy="4754880"/>
+            <a:off x="868680" y="6035040"/>
+            <a:ext cx="10789920" cy="27432"/>
           </a:xfrm>
           <a:prstGeom prst="rect">
             <a:avLst/>
           </a:prstGeom>
           <a:solidFill>
-            <a:srgbClr val="FFFFFF"/>
+            <a:srgbClr val="C79948"/>
           </a:solidFill>
           <a:ln>
-            <a:solidFill>
-              <a:srgbClr val="D8DFE8"/>
-            </a:solidFill>
+            <a:noFill/>
           </a:ln>
         </p:spPr>
         <p:style>
@@ -4915,59 +5953,14 @@
       </p:sp>
       <p:sp>
         <p:nvSpPr>
-          <p:cNvPr id="6" name="Rectangle 5"/>
-          <p:cNvSpPr/>
-          <p:nvPr/>
-        </p:nvSpPr>
-        <p:spPr>
-          <a:xfrm>
-            <a:off x="6126480" y="1737360"/>
-            <a:ext cx="5440680" cy="4754880"/>
-          </a:xfrm>
-          <a:prstGeom prst="rect">
-            <a:avLst/>
-          </a:prstGeom>
-          <a:solidFill>
-            <a:srgbClr val="FFFFFF"/>
-          </a:solidFill>
-          <a:ln>
-            <a:solidFill>
-              <a:srgbClr val="D8DFE8"/>
-            </a:solidFill>
-          </a:ln>
-        </p:spPr>
-        <p:style>
-          <a:lnRef idx="1">
-            <a:schemeClr val="accent1"/>
-          </a:lnRef>
-          <a:fillRef idx="3">
-            <a:schemeClr val="accent1"/>
-          </a:fillRef>
-          <a:effectRef idx="2">
-            <a:schemeClr val="accent1"/>
-          </a:effectRef>
-          <a:fontRef idx="minor">
-            <a:schemeClr val="lt1"/>
-          </a:fontRef>
-        </p:style>
-        <p:txBody>
-          <a:bodyPr rtlCol="0" anchor="ctr"/>
-          <a:lstStyle/>
-          <a:p>
-            <a:pPr algn="ctr"/>
-          </a:p>
-        </p:txBody>
-      </p:sp>
-      <p:sp>
-        <p:nvSpPr>
           <p:cNvPr id="7" name="TextBox 6"/>
           <p:cNvSpPr txBox="1"/>
           <p:nvPr/>
         </p:nvSpPr>
         <p:spPr>
           <a:xfrm>
-            <a:off x="868680" y="1965960"/>
-            <a:ext cx="4983480" cy="457200"/>
+            <a:off x="868680" y="6144768"/>
+            <a:ext cx="10789920" cy="548640"/>
           </a:xfrm>
           <a:prstGeom prst="rect">
             <a:avLst/>
@@ -4981,221 +5974,13 @@
           <a:lstStyle/>
           <a:p>
             <a:r>
-              <a:rPr sz="2000" b="1">
-                <a:solidFill>
-                  <a:srgbClr val="12233F"/>
+              <a:rPr sz="1400">
+                <a:solidFill>
+                  <a:srgbClr val="364559"/>
                 </a:solidFill>
                 <a:latin typeface="Calibri"/>
               </a:rPr>
-              <a:t>Thailand + Vietnam</a:t>
-            </a:r>
-          </a:p>
-        </p:txBody>
-      </p:sp>
-      <p:sp>
-        <p:nvSpPr>
-          <p:cNvPr id="8" name="TextBox 7"/>
-          <p:cNvSpPr txBox="1"/>
-          <p:nvPr/>
-        </p:nvSpPr>
-        <p:spPr>
-          <a:xfrm>
-            <a:off x="868680" y="2514600"/>
-            <a:ext cx="4892040" cy="3749039"/>
-          </a:xfrm>
-          <a:prstGeom prst="rect">
-            <a:avLst/>
-          </a:prstGeom>
-          <a:noFill/>
-        </p:spPr>
-        <p:txBody>
-          <a:bodyPr wrap="square">
-            <a:spAutoFit/>
-          </a:bodyPr>
-          <a:lstStyle/>
-          <a:p>
-            <a:pPr>
-              <a:spcAft>
-                <a:spcPts val="1000"/>
-              </a:spcAft>
-              <a:defRPr sz="1600">
-                <a:solidFill>
-                  <a:srgbClr val="364559"/>
-                </a:solidFill>
-                <a:latin typeface="Calibri"/>
-              </a:defRPr>
-            </a:pPr>
-            <a:r>
-              <a:t>Position portfolio by channel: modern trade, convenience, and on-trade activation.</a:t>
-            </a:r>
-          </a:p>
-          <a:p>
-            <a:pPr>
-              <a:spcAft>
-                <a:spcPts val="1000"/>
-              </a:spcAft>
-              <a:defRPr sz="1600">
-                <a:solidFill>
-                  <a:srgbClr val="364559"/>
-                </a:solidFill>
-                <a:latin typeface="Calibri"/>
-              </a:defRPr>
-            </a:pPr>
-            <a:r>
-              <a:t>Set margin architecture for producers, importers/distributors, and retailers.</a:t>
-            </a:r>
-          </a:p>
-          <a:p>
-            <a:pPr>
-              <a:spcAft>
-                <a:spcPts val="1000"/>
-              </a:spcAft>
-              <a:defRPr sz="1600">
-                <a:solidFill>
-                  <a:srgbClr val="364559"/>
-                </a:solidFill>
-                <a:latin typeface="Calibri"/>
-              </a:defRPr>
-            </a:pPr>
-            <a:r>
-              <a:t>Build launch calendars tied to local demand windows, events, and consumer behavior.</a:t>
-            </a:r>
-          </a:p>
-          <a:p>
-            <a:pPr>
-              <a:spcAft>
-                <a:spcPts val="1000"/>
-              </a:spcAft>
-              <a:defRPr sz="1600">
-                <a:solidFill>
-                  <a:srgbClr val="364559"/>
-                </a:solidFill>
-                <a:latin typeface="Calibri"/>
-              </a:defRPr>
-            </a:pPr>
-            <a:r>
-              <a:t>Run SKU-by-SKU pricing ladders to protect both velocity and gross margin.</a:t>
-            </a:r>
-          </a:p>
-        </p:txBody>
-      </p:sp>
-      <p:sp>
-        <p:nvSpPr>
-          <p:cNvPr id="9" name="TextBox 8"/>
-          <p:cNvSpPr txBox="1"/>
-          <p:nvPr/>
-        </p:nvSpPr>
-        <p:spPr>
-          <a:xfrm>
-            <a:off x="6355080" y="1965960"/>
-            <a:ext cx="4983480" cy="457200"/>
-          </a:xfrm>
-          <a:prstGeom prst="rect">
-            <a:avLst/>
-          </a:prstGeom>
-          <a:noFill/>
-        </p:spPr>
-        <p:txBody>
-          <a:bodyPr wrap="none">
-            <a:spAutoFit/>
-          </a:bodyPr>
-          <a:lstStyle/>
-          <a:p>
-            <a:r>
-              <a:rPr sz="2000" b="1">
-                <a:solidFill>
-                  <a:srgbClr val="12233F"/>
-                </a:solidFill>
-                <a:latin typeface="Calibri"/>
-              </a:rPr>
-              <a:t>Laos Market Entry</a:t>
-            </a:r>
-          </a:p>
-        </p:txBody>
-      </p:sp>
-      <p:sp>
-        <p:nvSpPr>
-          <p:cNvPr id="10" name="TextBox 9"/>
-          <p:cNvSpPr txBox="1"/>
-          <p:nvPr/>
-        </p:nvSpPr>
-        <p:spPr>
-          <a:xfrm>
-            <a:off x="6355080" y="2514600"/>
-            <a:ext cx="4892040" cy="3749039"/>
-          </a:xfrm>
-          <a:prstGeom prst="rect">
-            <a:avLst/>
-          </a:prstGeom>
-          <a:noFill/>
-        </p:spPr>
-        <p:txBody>
-          <a:bodyPr wrap="square">
-            <a:spAutoFit/>
-          </a:bodyPr>
-          <a:lstStyle/>
-          <a:p>
-            <a:pPr>
-              <a:spcAft>
-                <a:spcPts val="1000"/>
-              </a:spcAft>
-              <a:defRPr sz="1600">
-                <a:solidFill>
-                  <a:srgbClr val="364559"/>
-                </a:solidFill>
-                <a:latin typeface="Calibri"/>
-              </a:defRPr>
-            </a:pPr>
-            <a:r>
-              <a:t>Define import or local production model based on tax and duty realities.</a:t>
-            </a:r>
-          </a:p>
-          <a:p>
-            <a:pPr>
-              <a:spcAft>
-                <a:spcPts val="1000"/>
-              </a:spcAft>
-              <a:defRPr sz="1600">
-                <a:solidFill>
-                  <a:srgbClr val="364559"/>
-                </a:solidFill>
-                <a:latin typeface="Calibri"/>
-              </a:defRPr>
-            </a:pPr>
-            <a:r>
-              <a:t>Build first-wave assortment with clear opening price points and premium anchors.</a:t>
-            </a:r>
-          </a:p>
-          <a:p>
-            <a:pPr>
-              <a:spcAft>
-                <a:spcPts val="1000"/>
-              </a:spcAft>
-              <a:defRPr sz="1600">
-                <a:solidFill>
-                  <a:srgbClr val="364559"/>
-                </a:solidFill>
-                <a:latin typeface="Calibri"/>
-              </a:defRPr>
-            </a:pPr>
-            <a:r>
-              <a:t>Train distributor teams on product story, outlet pitch, and sell-in mechanics.</a:t>
-            </a:r>
-          </a:p>
-          <a:p>
-            <a:pPr>
-              <a:spcAft>
-                <a:spcPts val="1000"/>
-              </a:spcAft>
-              <a:defRPr sz="1600">
-                <a:solidFill>
-                  <a:srgbClr val="364559"/>
-                </a:solidFill>
-                <a:latin typeface="Calibri"/>
-              </a:defRPr>
-            </a:pPr>
-            <a:r>
-              <a:t>Stage rollout by city and outlet class to maximize conversion with controlled risk.</a:t>
+              <a:t>Result: diversified supply continuity with practical production optionality across countries and categories.</a:t>
             </a:r>
           </a:p>
         </p:txBody>
@@ -5308,7 +6093,7 @@
                 </a:solidFill>
                 <a:latin typeface="Calibri"/>
               </a:rPr>
-              <a:t>Relationships</a:t>
+              <a:t>Regional Commercialization</a:t>
             </a:r>
           </a:p>
         </p:txBody>
@@ -5342,7 +6127,7 @@
                 </a:solidFill>
                 <a:latin typeface="Calibri"/>
               </a:rPr>
-              <a:t>A Working Network Built Over a Decade</a:t>
+              <a:t>Route-to-Market and Pricing Strategy by Market</a:t>
             </a:r>
           </a:p>
         </p:txBody>
@@ -5466,7 +6251,7 @@
                 </a:solidFill>
                 <a:latin typeface="Calibri"/>
               </a:rPr>
-              <a:t>Supply + Production Partners</a:t>
+              <a:t>Thailand + Vietnam</a:t>
             </a:r>
           </a:p>
         </p:txBody>
@@ -5505,7 +6290,7 @@
               </a:defRPr>
             </a:pPr>
             <a:r>
-              <a:t>Hop and ingredient suppliers in the USA and New Zealand.</a:t>
+              <a:t>Position portfolio by channel: modern trade, convenience, and on-trade activation.</a:t>
             </a:r>
           </a:p>
           <a:p>
@@ -5521,7 +6306,7 @@
               </a:defRPr>
             </a:pPr>
             <a:r>
-              <a:t>Manufacturing partners in Thailand and Vietnam covering beer, spirits, and RTD.</a:t>
+              <a:t>Set margin architecture for producers, importers/distributors, and retailers.</a:t>
             </a:r>
           </a:p>
           <a:p>
@@ -5537,7 +6322,7 @@
               </a:defRPr>
             </a:pPr>
             <a:r>
-              <a:t>Packaging suppliers for cans, bottles, cartons, and labels with scalable capacity.</a:t>
+              <a:t>Build launch calendars tied to local demand windows, events, and consumer behavior.</a:t>
             </a:r>
           </a:p>
           <a:p>
@@ -5553,7 +6338,7 @@
               </a:defRPr>
             </a:pPr>
             <a:r>
-              <a:t>Quality and operational alignment across partners to speed launch readiness.</a:t>
+              <a:t>Run SKU-by-SKU pricing ladders to protect both velocity and gross margin.</a:t>
             </a:r>
           </a:p>
         </p:txBody>
@@ -5587,7 +6372,7 @@
                 </a:solidFill>
                 <a:latin typeface="Calibri"/>
               </a:rPr>
-              <a:t>Commercial Partners</a:t>
+              <a:t>Laos Market Entry</a:t>
             </a:r>
           </a:p>
         </p:txBody>
@@ -5626,7 +6411,7 @@
               </a:defRPr>
             </a:pPr>
             <a:r>
-              <a:t>Distributors and route-to-market operators across Thailand, Laos, and Vietnam.</a:t>
+              <a:t>Define import or local production model based on tax and duty realities.</a:t>
             </a:r>
           </a:p>
           <a:p>
@@ -5642,7 +6427,7 @@
               </a:defRPr>
             </a:pPr>
             <a:r>
-              <a:t>Retail and convenience channel relationships in Taiwan and Japan export routes.</a:t>
+              <a:t>Build first-wave assortment with clear opening price points and premium anchors.</a:t>
             </a:r>
           </a:p>
           <a:p>
@@ -5658,7 +6443,7 @@
               </a:defRPr>
             </a:pPr>
             <a:r>
-              <a:t>On-trade account development through practical pricing and menu placement strategy.</a:t>
+              <a:t>Train distributor teams on product story, outlet pitch, and sell-in mechanics.</a:t>
             </a:r>
           </a:p>
           <a:p>
@@ -5674,7 +6459,7 @@
               </a:defRPr>
             </a:pPr>
             <a:r>
-              <a:t>Cross-functional partner management to maintain execution standards and timelines.</a:t>
+              <a:t>Stage rollout by city and outlet class to maximize conversion with controlled risk.</a:t>
             </a:r>
           </a:p>
         </p:txBody>
@@ -5787,7 +6572,7 @@
                 </a:solidFill>
                 <a:latin typeface="Calibri"/>
               </a:rPr>
-              <a:t>Category Scope</a:t>
+              <a:t>Relationships</a:t>
             </a:r>
           </a:p>
         </p:txBody>
@@ -5815,27 +6600,151 @@
           <a:lstStyle/>
           <a:p>
             <a:r>
-              <a:rPr sz="3400" b="1">
+              <a:rPr sz="3000" b="1">
                 <a:solidFill>
                   <a:srgbClr val="12233F"/>
                 </a:solidFill>
                 <a:latin typeface="Calibri"/>
               </a:rPr>
-              <a:t>Cross-Category Execution Capabilities</a:t>
-            </a:r>
-          </a:p>
-        </p:txBody>
-      </p:sp>
-      <p:sp>
-        <p:nvSpPr>
-          <p:cNvPr id="5" name="TextBox 4"/>
+              <a:t>A Working Network Built Over a Decade</a:t>
+            </a:r>
+          </a:p>
+        </p:txBody>
+      </p:sp>
+      <p:sp>
+        <p:nvSpPr>
+          <p:cNvPr id="5" name="Rectangle 4"/>
+          <p:cNvSpPr/>
+          <p:nvPr/>
+        </p:nvSpPr>
+        <p:spPr>
+          <a:xfrm>
+            <a:off x="640080" y="1737360"/>
+            <a:ext cx="5440680" cy="4754880"/>
+          </a:xfrm>
+          <a:prstGeom prst="rect">
+            <a:avLst/>
+          </a:prstGeom>
+          <a:solidFill>
+            <a:srgbClr val="FFFFFF"/>
+          </a:solidFill>
+          <a:ln>
+            <a:solidFill>
+              <a:srgbClr val="D8DFE8"/>
+            </a:solidFill>
+          </a:ln>
+        </p:spPr>
+        <p:style>
+          <a:lnRef idx="1">
+            <a:schemeClr val="accent1"/>
+          </a:lnRef>
+          <a:fillRef idx="3">
+            <a:schemeClr val="accent1"/>
+          </a:fillRef>
+          <a:effectRef idx="2">
+            <a:schemeClr val="accent1"/>
+          </a:effectRef>
+          <a:fontRef idx="minor">
+            <a:schemeClr val="lt1"/>
+          </a:fontRef>
+        </p:style>
+        <p:txBody>
+          <a:bodyPr rtlCol="0" anchor="ctr"/>
+          <a:lstStyle/>
+          <a:p>
+            <a:pPr algn="ctr"/>
+          </a:p>
+        </p:txBody>
+      </p:sp>
+      <p:sp>
+        <p:nvSpPr>
+          <p:cNvPr id="6" name="Rectangle 5"/>
+          <p:cNvSpPr/>
+          <p:nvPr/>
+        </p:nvSpPr>
+        <p:spPr>
+          <a:xfrm>
+            <a:off x="6126480" y="1737360"/>
+            <a:ext cx="5440680" cy="4754880"/>
+          </a:xfrm>
+          <a:prstGeom prst="rect">
+            <a:avLst/>
+          </a:prstGeom>
+          <a:solidFill>
+            <a:srgbClr val="FFFFFF"/>
+          </a:solidFill>
+          <a:ln>
+            <a:solidFill>
+              <a:srgbClr val="D8DFE8"/>
+            </a:solidFill>
+          </a:ln>
+        </p:spPr>
+        <p:style>
+          <a:lnRef idx="1">
+            <a:schemeClr val="accent1"/>
+          </a:lnRef>
+          <a:fillRef idx="3">
+            <a:schemeClr val="accent1"/>
+          </a:fillRef>
+          <a:effectRef idx="2">
+            <a:schemeClr val="accent1"/>
+          </a:effectRef>
+          <a:fontRef idx="minor">
+            <a:schemeClr val="lt1"/>
+          </a:fontRef>
+        </p:style>
+        <p:txBody>
+          <a:bodyPr rtlCol="0" anchor="ctr"/>
+          <a:lstStyle/>
+          <a:p>
+            <a:pPr algn="ctr"/>
+          </a:p>
+        </p:txBody>
+      </p:sp>
+      <p:sp>
+        <p:nvSpPr>
+          <p:cNvPr id="7" name="TextBox 6"/>
           <p:cNvSpPr txBox="1"/>
           <p:nvPr/>
         </p:nvSpPr>
         <p:spPr>
           <a:xfrm>
-            <a:off x="868680" y="1645920"/>
-            <a:ext cx="10789920" cy="4480560"/>
+            <a:off x="868680" y="1965960"/>
+            <a:ext cx="4983480" cy="457200"/>
+          </a:xfrm>
+          <a:prstGeom prst="rect">
+            <a:avLst/>
+          </a:prstGeom>
+          <a:noFill/>
+        </p:spPr>
+        <p:txBody>
+          <a:bodyPr wrap="none">
+            <a:spAutoFit/>
+          </a:bodyPr>
+          <a:lstStyle/>
+          <a:p>
+            <a:r>
+              <a:rPr sz="2000" b="1">
+                <a:solidFill>
+                  <a:srgbClr val="12233F"/>
+                </a:solidFill>
+                <a:latin typeface="Calibri"/>
+              </a:rPr>
+              <a:t>Supply + Production Partners</a:t>
+            </a:r>
+          </a:p>
+        </p:txBody>
+      </p:sp>
+      <p:sp>
+        <p:nvSpPr>
+          <p:cNvPr id="8" name="TextBox 7"/>
+          <p:cNvSpPr txBox="1"/>
+          <p:nvPr/>
+        </p:nvSpPr>
+        <p:spPr>
+          <a:xfrm>
+            <a:off x="868680" y="2514600"/>
+            <a:ext cx="4892040" cy="3749039"/>
           </a:xfrm>
           <a:prstGeom prst="rect">
             <a:avLst/>
@@ -5850,9 +6759,9 @@
           <a:p>
             <a:pPr>
               <a:spcAft>
-                <a:spcPts val="1400"/>
+                <a:spcPts val="1000"/>
               </a:spcAft>
-              <a:defRPr sz="2400">
+              <a:defRPr sz="1600">
                 <a:solidFill>
                   <a:srgbClr val="364559"/>
                 </a:solidFill>
@@ -5860,15 +6769,15 @@
               </a:defRPr>
             </a:pPr>
             <a:r>
-              <a:t>Brewery: concept-to-commercialization support for craft and premium beer portfolios.</a:t>
+              <a:t>Hop and ingredient suppliers in the USA and New Zealand.</a:t>
             </a:r>
           </a:p>
           <a:p>
             <a:pPr>
               <a:spcAft>
-                <a:spcPts val="1400"/>
+                <a:spcPts val="1000"/>
               </a:spcAft>
-              <a:defRPr sz="2000">
+              <a:defRPr sz="1600">
                 <a:solidFill>
                   <a:srgbClr val="364559"/>
                 </a:solidFill>
@@ -5876,15 +6785,15 @@
               </a:defRPr>
             </a:pPr>
             <a:r>
-              <a:t>Distillery: liquid positioning, production planning, and go-to-market design for spirits.</a:t>
+              <a:t>Manufacturing partners in Thailand and Vietnam covering beer, spirits, and RTD.</a:t>
             </a:r>
           </a:p>
           <a:p>
             <a:pPr>
               <a:spcAft>
-                <a:spcPts val="1400"/>
+                <a:spcPts val="1000"/>
               </a:spcAft>
-              <a:defRPr sz="2000">
+              <a:defRPr sz="1600">
                 <a:solidFill>
                   <a:srgbClr val="364559"/>
                 </a:solidFill>
@@ -5892,15 +6801,15 @@
               </a:defRPr>
             </a:pPr>
             <a:r>
-              <a:t>RTD: speed-to-market product development and scalable production transition support.</a:t>
+              <a:t>Packaging suppliers for cans, bottles, cartons, and labels with scalable capacity.</a:t>
             </a:r>
           </a:p>
           <a:p>
             <a:pPr>
               <a:spcAft>
-                <a:spcPts val="1400"/>
+                <a:spcPts val="1000"/>
               </a:spcAft>
-              <a:defRPr sz="2000">
+              <a:defRPr sz="1600">
                 <a:solidFill>
                   <a:srgbClr val="364559"/>
                 </a:solidFill>
@@ -5908,7 +6817,128 @@
               </a:defRPr>
             </a:pPr>
             <a:r>
-              <a:t>Integrated portfolio strategy to prevent channel conflict and maximize total account value.</a:t>
+              <a:t>Quality and operational alignment across partners to speed launch readiness.</a:t>
+            </a:r>
+          </a:p>
+        </p:txBody>
+      </p:sp>
+      <p:sp>
+        <p:nvSpPr>
+          <p:cNvPr id="9" name="TextBox 8"/>
+          <p:cNvSpPr txBox="1"/>
+          <p:nvPr/>
+        </p:nvSpPr>
+        <p:spPr>
+          <a:xfrm>
+            <a:off x="6355080" y="1965960"/>
+            <a:ext cx="4983480" cy="457200"/>
+          </a:xfrm>
+          <a:prstGeom prst="rect">
+            <a:avLst/>
+          </a:prstGeom>
+          <a:noFill/>
+        </p:spPr>
+        <p:txBody>
+          <a:bodyPr wrap="none">
+            <a:spAutoFit/>
+          </a:bodyPr>
+          <a:lstStyle/>
+          <a:p>
+            <a:r>
+              <a:rPr sz="2000" b="1">
+                <a:solidFill>
+                  <a:srgbClr val="12233F"/>
+                </a:solidFill>
+                <a:latin typeface="Calibri"/>
+              </a:rPr>
+              <a:t>Commercial Partners</a:t>
+            </a:r>
+          </a:p>
+        </p:txBody>
+      </p:sp>
+      <p:sp>
+        <p:nvSpPr>
+          <p:cNvPr id="10" name="TextBox 9"/>
+          <p:cNvSpPr txBox="1"/>
+          <p:nvPr/>
+        </p:nvSpPr>
+        <p:spPr>
+          <a:xfrm>
+            <a:off x="6355080" y="2514600"/>
+            <a:ext cx="4892040" cy="3749039"/>
+          </a:xfrm>
+          <a:prstGeom prst="rect">
+            <a:avLst/>
+          </a:prstGeom>
+          <a:noFill/>
+        </p:spPr>
+        <p:txBody>
+          <a:bodyPr wrap="square">
+            <a:spAutoFit/>
+          </a:bodyPr>
+          <a:lstStyle/>
+          <a:p>
+            <a:pPr>
+              <a:spcAft>
+                <a:spcPts val="1000"/>
+              </a:spcAft>
+              <a:defRPr sz="1600">
+                <a:solidFill>
+                  <a:srgbClr val="364559"/>
+                </a:solidFill>
+                <a:latin typeface="Calibri"/>
+              </a:defRPr>
+            </a:pPr>
+            <a:r>
+              <a:t>Distributors and route-to-market operators across Thailand, Laos, and Vietnam.</a:t>
+            </a:r>
+          </a:p>
+          <a:p>
+            <a:pPr>
+              <a:spcAft>
+                <a:spcPts val="1000"/>
+              </a:spcAft>
+              <a:defRPr sz="1600">
+                <a:solidFill>
+                  <a:srgbClr val="364559"/>
+                </a:solidFill>
+                <a:latin typeface="Calibri"/>
+              </a:defRPr>
+            </a:pPr>
+            <a:r>
+              <a:t>Retail and convenience channel relationships in Taiwan and Japan export routes.</a:t>
+            </a:r>
+          </a:p>
+          <a:p>
+            <a:pPr>
+              <a:spcAft>
+                <a:spcPts val="1000"/>
+              </a:spcAft>
+              <a:defRPr sz="1600">
+                <a:solidFill>
+                  <a:srgbClr val="364559"/>
+                </a:solidFill>
+                <a:latin typeface="Calibri"/>
+              </a:defRPr>
+            </a:pPr>
+            <a:r>
+              <a:t>On-trade account development through practical pricing and menu placement strategy.</a:t>
+            </a:r>
+          </a:p>
+          <a:p>
+            <a:pPr>
+              <a:spcAft>
+                <a:spcPts val="1000"/>
+              </a:spcAft>
+              <a:defRPr sz="1600">
+                <a:solidFill>
+                  <a:srgbClr val="364559"/>
+                </a:solidFill>
+                <a:latin typeface="Calibri"/>
+              </a:defRPr>
+            </a:pPr>
+            <a:r>
+              <a:t>Cross-functional partner management to maintain execution standards and timelines.</a:t>
             </a:r>
           </a:p>
         </p:txBody>
@@ -6021,7 +7051,7 @@
                 </a:solidFill>
                 <a:latin typeface="Calibri"/>
               </a:rPr>
-              <a:t>Commercial Evidence</a:t>
+              <a:t>Category Scope</a:t>
             </a:r>
           </a:p>
         </p:txBody>
@@ -6055,7 +7085,7 @@
                 </a:solidFill>
                 <a:latin typeface="Calibri"/>
               </a:rPr>
-              <a:t>Selected Outcomes Delivered</a:t>
+              <a:t>Cross-Category Execution Capabilities</a:t>
             </a:r>
           </a:p>
         </p:txBody>
@@ -6094,7 +7124,7 @@
               </a:defRPr>
             </a:pPr>
             <a:r>
-              <a:t>Built and operated systems behind Mahanakhon products now exceeding $2M annual retail + on-trade revenue.</a:t>
+              <a:t>Brewery: concept-to-commercialization support for craft and premium beer portfolios.</a:t>
             </a:r>
           </a:p>
           <a:p>
@@ -6110,7 +7140,7 @@
               </a:defRPr>
             </a:pPr>
             <a:r>
-              <a:t>Structured practical supply chain pathways linking global ingredient sourcing to regional production execution.</a:t>
+              <a:t>Distillery: liquid positioning, production planning, and go-to-market design for spirits.</a:t>
             </a:r>
           </a:p>
           <a:p>
@@ -6126,7 +7156,7 @@
               </a:defRPr>
             </a:pPr>
             <a:r>
-              <a:t>Developed export-ready operating flows for convenience store channels in Taiwan and Japan.</a:t>
+              <a:t>RTD: speed-to-market product development and scalable production transition support.</a:t>
             </a:r>
           </a:p>
           <a:p>
@@ -6142,84 +7172,7 @@
               </a:defRPr>
             </a:pPr>
             <a:r>
-              <a:t>Supported market-opening strategy for Laos with channel-specific launch sequencing and price architecture.</a:t>
-            </a:r>
-          </a:p>
-        </p:txBody>
-      </p:sp>
-      <p:sp>
-        <p:nvSpPr>
-          <p:cNvPr id="6" name="Rectangle 5"/>
-          <p:cNvSpPr/>
-          <p:nvPr/>
-        </p:nvSpPr>
-        <p:spPr>
-          <a:xfrm>
-            <a:off x="868680" y="6035040"/>
-            <a:ext cx="10789920" cy="27432"/>
-          </a:xfrm>
-          <a:prstGeom prst="rect">
-            <a:avLst/>
-          </a:prstGeom>
-          <a:solidFill>
-            <a:srgbClr val="C79948"/>
-          </a:solidFill>
-          <a:ln>
-            <a:noFill/>
-          </a:ln>
-        </p:spPr>
-        <p:style>
-          <a:lnRef idx="1">
-            <a:schemeClr val="accent1"/>
-          </a:lnRef>
-          <a:fillRef idx="3">
-            <a:schemeClr val="accent1"/>
-          </a:fillRef>
-          <a:effectRef idx="2">
-            <a:schemeClr val="accent1"/>
-          </a:effectRef>
-          <a:fontRef idx="minor">
-            <a:schemeClr val="lt1"/>
-          </a:fontRef>
-        </p:style>
-        <p:txBody>
-          <a:bodyPr rtlCol="0" anchor="ctr"/>
-          <a:lstStyle/>
-          <a:p>
-            <a:pPr algn="ctr"/>
-          </a:p>
-        </p:txBody>
-      </p:sp>
-      <p:sp>
-        <p:nvSpPr>
-          <p:cNvPr id="7" name="TextBox 6"/>
-          <p:cNvSpPr txBox="1"/>
-          <p:nvPr/>
-        </p:nvSpPr>
-        <p:spPr>
-          <a:xfrm>
-            <a:off x="868680" y="6144768"/>
-            <a:ext cx="10789920" cy="548640"/>
-          </a:xfrm>
-          <a:prstGeom prst="rect">
-            <a:avLst/>
-          </a:prstGeom>
-          <a:noFill/>
-        </p:spPr>
-        <p:txBody>
-          <a:bodyPr wrap="none">
-            <a:spAutoFit/>
-          </a:bodyPr>
-          <a:lstStyle/>
-          <a:p>
-            <a:r>
-              <a:rPr sz="1400">
-                <a:solidFill>
-                  <a:srgbClr val="364559"/>
-                </a:solidFill>
-                <a:latin typeface="Calibri"/>
-              </a:rPr>
-              <a:t>All outcomes based on direct operating involvement in sourcing, production, and commercialization.</a:t>
+              <a:t>Integrated portfolio strategy to prevent channel conflict and maximize total account value.</a:t>
             </a:r>
           </a:p>
         </p:txBody>
@@ -6332,7 +7285,7 @@
                 </a:solidFill>
                 <a:latin typeface="Calibri"/>
               </a:rPr>
-              <a:t>Engagement Model</a:t>
+              <a:t>Commercial Evidence</a:t>
             </a:r>
           </a:p>
         </p:txBody>
@@ -6360,38 +7313,123 @@
           <a:lstStyle/>
           <a:p>
             <a:r>
-              <a:rPr sz="3000" b="1">
+              <a:rPr sz="3400" b="1">
                 <a:solidFill>
                   <a:srgbClr val="12233F"/>
                 </a:solidFill>
                 <a:latin typeface="Calibri"/>
               </a:rPr>
-              <a:t>How I Work With Beverage Companies</a:t>
-            </a:r>
-          </a:p>
-        </p:txBody>
-      </p:sp>
-      <p:sp>
-        <p:nvSpPr>
-          <p:cNvPr id="5" name="Rectangle 4"/>
+              <a:t>Selected Outcomes Delivered</a:t>
+            </a:r>
+          </a:p>
+        </p:txBody>
+      </p:sp>
+      <p:sp>
+        <p:nvSpPr>
+          <p:cNvPr id="5" name="TextBox 4"/>
+          <p:cNvSpPr txBox="1"/>
+          <p:nvPr/>
+        </p:nvSpPr>
+        <p:spPr>
+          <a:xfrm>
+            <a:off x="868680" y="1645920"/>
+            <a:ext cx="10789920" cy="4480560"/>
+          </a:xfrm>
+          <a:prstGeom prst="rect">
+            <a:avLst/>
+          </a:prstGeom>
+          <a:noFill/>
+        </p:spPr>
+        <p:txBody>
+          <a:bodyPr wrap="square">
+            <a:spAutoFit/>
+          </a:bodyPr>
+          <a:lstStyle/>
+          <a:p>
+            <a:pPr>
+              <a:spcAft>
+                <a:spcPts val="1400"/>
+              </a:spcAft>
+              <a:defRPr sz="2400">
+                <a:solidFill>
+                  <a:srgbClr val="364559"/>
+                </a:solidFill>
+                <a:latin typeface="Calibri"/>
+              </a:defRPr>
+            </a:pPr>
+            <a:r>
+              <a:t>Built and operated systems behind Mahanakhon products now exceeding $2M annual retail + on-trade revenue.</a:t>
+            </a:r>
+          </a:p>
+          <a:p>
+            <a:pPr>
+              <a:spcAft>
+                <a:spcPts val="1400"/>
+              </a:spcAft>
+              <a:defRPr sz="2000">
+                <a:solidFill>
+                  <a:srgbClr val="364559"/>
+                </a:solidFill>
+                <a:latin typeface="Calibri"/>
+              </a:defRPr>
+            </a:pPr>
+            <a:r>
+              <a:t>Structured practical supply chain pathways linking global ingredient sourcing to regional production execution.</a:t>
+            </a:r>
+          </a:p>
+          <a:p>
+            <a:pPr>
+              <a:spcAft>
+                <a:spcPts val="1400"/>
+              </a:spcAft>
+              <a:defRPr sz="2000">
+                <a:solidFill>
+                  <a:srgbClr val="364559"/>
+                </a:solidFill>
+                <a:latin typeface="Calibri"/>
+              </a:defRPr>
+            </a:pPr>
+            <a:r>
+              <a:t>Developed export-ready operating flows for convenience store channels in Taiwan and Japan.</a:t>
+            </a:r>
+          </a:p>
+          <a:p>
+            <a:pPr>
+              <a:spcAft>
+                <a:spcPts val="1400"/>
+              </a:spcAft>
+              <a:defRPr sz="2000">
+                <a:solidFill>
+                  <a:srgbClr val="364559"/>
+                </a:solidFill>
+                <a:latin typeface="Calibri"/>
+              </a:defRPr>
+            </a:pPr>
+            <a:r>
+              <a:t>Supported market-opening strategy for Laos with channel-specific launch sequencing and price architecture.</a:t>
+            </a:r>
+          </a:p>
+        </p:txBody>
+      </p:sp>
+      <p:sp>
+        <p:nvSpPr>
+          <p:cNvPr id="6" name="Rectangle 5"/>
           <p:cNvSpPr/>
           <p:nvPr/>
         </p:nvSpPr>
         <p:spPr>
           <a:xfrm>
-            <a:off x="640080" y="1737360"/>
-            <a:ext cx="5440680" cy="4754880"/>
+            <a:off x="868680" y="6035040"/>
+            <a:ext cx="10789920" cy="27432"/>
           </a:xfrm>
           <a:prstGeom prst="rect">
             <a:avLst/>
           </a:prstGeom>
           <a:solidFill>
-            <a:srgbClr val="FFFFFF"/>
+            <a:srgbClr val="C79948"/>
           </a:solidFill>
           <a:ln>
-            <a:solidFill>
-              <a:srgbClr val="D8DFE8"/>
-            </a:solidFill>
+            <a:noFill/>
           </a:ln>
         </p:spPr>
         <p:style>
@@ -6418,59 +7456,14 @@
       </p:sp>
       <p:sp>
         <p:nvSpPr>
-          <p:cNvPr id="6" name="Rectangle 5"/>
-          <p:cNvSpPr/>
-          <p:nvPr/>
-        </p:nvSpPr>
-        <p:spPr>
-          <a:xfrm>
-            <a:off x="6126480" y="1737360"/>
-            <a:ext cx="5440680" cy="4754880"/>
-          </a:xfrm>
-          <a:prstGeom prst="rect">
-            <a:avLst/>
-          </a:prstGeom>
-          <a:solidFill>
-            <a:srgbClr val="FFFFFF"/>
-          </a:solidFill>
-          <a:ln>
-            <a:solidFill>
-              <a:srgbClr val="D8DFE8"/>
-            </a:solidFill>
-          </a:ln>
-        </p:spPr>
-        <p:style>
-          <a:lnRef idx="1">
-            <a:schemeClr val="accent1"/>
-          </a:lnRef>
-          <a:fillRef idx="3">
-            <a:schemeClr val="accent1"/>
-          </a:fillRef>
-          <a:effectRef idx="2">
-            <a:schemeClr val="accent1"/>
-          </a:effectRef>
-          <a:fontRef idx="minor">
-            <a:schemeClr val="lt1"/>
-          </a:fontRef>
-        </p:style>
-        <p:txBody>
-          <a:bodyPr rtlCol="0" anchor="ctr"/>
-          <a:lstStyle/>
-          <a:p>
-            <a:pPr algn="ctr"/>
-          </a:p>
-        </p:txBody>
-      </p:sp>
-      <p:sp>
-        <p:nvSpPr>
           <p:cNvPr id="7" name="TextBox 6"/>
           <p:cNvSpPr txBox="1"/>
           <p:nvPr/>
         </p:nvSpPr>
         <p:spPr>
           <a:xfrm>
-            <a:off x="868680" y="1965960"/>
-            <a:ext cx="4983480" cy="457200"/>
+            <a:off x="868680" y="6144768"/>
+            <a:ext cx="10789920" cy="548640"/>
           </a:xfrm>
           <a:prstGeom prst="rect">
             <a:avLst/>
@@ -6484,221 +7477,13 @@
           <a:lstStyle/>
           <a:p>
             <a:r>
-              <a:rPr sz="2000" b="1">
-                <a:solidFill>
-                  <a:srgbClr val="12233F"/>
+              <a:rPr sz="1400">
+                <a:solidFill>
+                  <a:srgbClr val="364559"/>
                 </a:solidFill>
                 <a:latin typeface="Calibri"/>
               </a:rPr>
-              <a:t>Advisory + Operating Sprint</a:t>
-            </a:r>
-          </a:p>
-        </p:txBody>
-      </p:sp>
-      <p:sp>
-        <p:nvSpPr>
-          <p:cNvPr id="8" name="TextBox 7"/>
-          <p:cNvSpPr txBox="1"/>
-          <p:nvPr/>
-        </p:nvSpPr>
-        <p:spPr>
-          <a:xfrm>
-            <a:off x="868680" y="2514600"/>
-            <a:ext cx="4892040" cy="3749039"/>
-          </a:xfrm>
-          <a:prstGeom prst="rect">
-            <a:avLst/>
-          </a:prstGeom>
-          <a:noFill/>
-        </p:spPr>
-        <p:txBody>
-          <a:bodyPr wrap="square">
-            <a:spAutoFit/>
-          </a:bodyPr>
-          <a:lstStyle/>
-          <a:p>
-            <a:pPr>
-              <a:spcAft>
-                <a:spcPts val="1000"/>
-              </a:spcAft>
-              <a:defRPr sz="1600">
-                <a:solidFill>
-                  <a:srgbClr val="364559"/>
-                </a:solidFill>
-                <a:latin typeface="Calibri"/>
-              </a:defRPr>
-            </a:pPr>
-            <a:r>
-              <a:t>30-90 day focused engagements for market entry, product launch, or supply chain redesign.</a:t>
-            </a:r>
-          </a:p>
-          <a:p>
-            <a:pPr>
-              <a:spcAft>
-                <a:spcPts val="1000"/>
-              </a:spcAft>
-              <a:defRPr sz="1600">
-                <a:solidFill>
-                  <a:srgbClr val="364559"/>
-                </a:solidFill>
-                <a:latin typeface="Calibri"/>
-              </a:defRPr>
-            </a:pPr>
-            <a:r>
-              <a:t>Workstreams: sourcing, plant partner selection, packaging readiness, pricing, and channel plan.</a:t>
-            </a:r>
-          </a:p>
-          <a:p>
-            <a:pPr>
-              <a:spcAft>
-                <a:spcPts val="1000"/>
-              </a:spcAft>
-              <a:defRPr sz="1600">
-                <a:solidFill>
-                  <a:srgbClr val="364559"/>
-                </a:solidFill>
-                <a:latin typeface="Calibri"/>
-              </a:defRPr>
-            </a:pPr>
-            <a:r>
-              <a:t>Weekly decision cadence with leadership team and execution owners.</a:t>
-            </a:r>
-          </a:p>
-          <a:p>
-            <a:pPr>
-              <a:spcAft>
-                <a:spcPts val="1000"/>
-              </a:spcAft>
-              <a:defRPr sz="1600">
-                <a:solidFill>
-                  <a:srgbClr val="364559"/>
-                </a:solidFill>
-                <a:latin typeface="Calibri"/>
-              </a:defRPr>
-            </a:pPr>
-            <a:r>
-              <a:t>Output: clear operating playbook with accountability and rollout checkpoints.</a:t>
-            </a:r>
-          </a:p>
-        </p:txBody>
-      </p:sp>
-      <p:sp>
-        <p:nvSpPr>
-          <p:cNvPr id="9" name="TextBox 8"/>
-          <p:cNvSpPr txBox="1"/>
-          <p:nvPr/>
-        </p:nvSpPr>
-        <p:spPr>
-          <a:xfrm>
-            <a:off x="6355080" y="1965960"/>
-            <a:ext cx="4983480" cy="457200"/>
-          </a:xfrm>
-          <a:prstGeom prst="rect">
-            <a:avLst/>
-          </a:prstGeom>
-          <a:noFill/>
-        </p:spPr>
-        <p:txBody>
-          <a:bodyPr wrap="none">
-            <a:spAutoFit/>
-          </a:bodyPr>
-          <a:lstStyle/>
-          <a:p>
-            <a:r>
-              <a:rPr sz="2000" b="1">
-                <a:solidFill>
-                  <a:srgbClr val="12233F"/>
-                </a:solidFill>
-                <a:latin typeface="Calibri"/>
-              </a:rPr>
-              <a:t>Fractional NPD Leadership</a:t>
-            </a:r>
-          </a:p>
-        </p:txBody>
-      </p:sp>
-      <p:sp>
-        <p:nvSpPr>
-          <p:cNvPr id="10" name="TextBox 9"/>
-          <p:cNvSpPr txBox="1"/>
-          <p:nvPr/>
-        </p:nvSpPr>
-        <p:spPr>
-          <a:xfrm>
-            <a:off x="6355080" y="2514600"/>
-            <a:ext cx="4892040" cy="3749039"/>
-          </a:xfrm>
-          <a:prstGeom prst="rect">
-            <a:avLst/>
-          </a:prstGeom>
-          <a:noFill/>
-        </p:spPr>
-        <p:txBody>
-          <a:bodyPr wrap="square">
-            <a:spAutoFit/>
-          </a:bodyPr>
-          <a:lstStyle/>
-          <a:p>
-            <a:pPr>
-              <a:spcAft>
-                <a:spcPts val="1000"/>
-              </a:spcAft>
-              <a:defRPr sz="1600">
-                <a:solidFill>
-                  <a:srgbClr val="364559"/>
-                </a:solidFill>
-                <a:latin typeface="Calibri"/>
-              </a:defRPr>
-            </a:pPr>
-            <a:r>
-              <a:t>Embedded support for teams that need senior NPD and commercialization leadership.</a:t>
-            </a:r>
-          </a:p>
-          <a:p>
-            <a:pPr>
-              <a:spcAft>
-                <a:spcPts val="1000"/>
-              </a:spcAft>
-              <a:defRPr sz="1600">
-                <a:solidFill>
-                  <a:srgbClr val="364559"/>
-                </a:solidFill>
-                <a:latin typeface="Calibri"/>
-              </a:defRPr>
-            </a:pPr>
-            <a:r>
-              <a:t>Cross-functional bridge between procurement, operations, marketing, and sales.</a:t>
-            </a:r>
-          </a:p>
-          <a:p>
-            <a:pPr>
-              <a:spcAft>
-                <a:spcPts val="1000"/>
-              </a:spcAft>
-              <a:defRPr sz="1600">
-                <a:solidFill>
-                  <a:srgbClr val="364559"/>
-                </a:solidFill>
-                <a:latin typeface="Calibri"/>
-              </a:defRPr>
-            </a:pPr>
-            <a:r>
-              <a:t>Focus on profitable scale, not just innovation theater.</a:t>
-            </a:r>
-          </a:p>
-          <a:p>
-            <a:pPr>
-              <a:spcAft>
-                <a:spcPts val="1000"/>
-              </a:spcAft>
-              <a:defRPr sz="1600">
-                <a:solidFill>
-                  <a:srgbClr val="364559"/>
-                </a:solidFill>
-                <a:latin typeface="Calibri"/>
-              </a:defRPr>
-            </a:pPr>
-            <a:r>
-              <a:t>Output: repeatable launch process that compounds over multiple product cycles.</a:t>
+              <a:t>All outcomes based on direct operating involvement in sourcing, production, and commercialization.</a:t>
             </a:r>
           </a:p>
         </p:txBody>

</xml_diff>